<commit_message>
Welle 3: VA10 kuratiertes Deck + 2 Schaubilder (Web/Admin/Workbook)
Co-Authored-By: Claude Fable 5 <noreply@anthropic.com>
</commit_message>
<xml_diff>
--- a/protected-downloads/praesentation/VA10.pptx
+++ b/protected-downloads/praesentation/VA10.pptx
@@ -13,6 +13,14 @@
     <p:sldId id="261" r:id="rId13"/>
     <p:sldId id="262" r:id="rId14"/>
     <p:sldId id="263" r:id="rId15"/>
+    <p:sldId id="264" r:id="rId16"/>
+    <p:sldId id="265" r:id="rId17"/>
+    <p:sldId id="266" r:id="rId18"/>
+    <p:sldId id="267" r:id="rId19"/>
+    <p:sldId id="268" r:id="rId20"/>
+    <p:sldId id="269" r:id="rId21"/>
+    <p:sldId id="270" r:id="rId22"/>
+    <p:sldId id="271" r:id="rId23"/>
   </p:sldIdLst>
   <p:sldSz cx="12188952" cy="6858000" type="screen4x3"/>
   <p:notesSz cx="6858000" cy="9144000"/>
@@ -579,7 +587,7 @@
           <a:lstStyle/>
           <a:p>
             <a:r>
-              <a:t>Siehe Trainerhandbuch (Sektion 3) für Moderationshinweise, Timing und erwartete Teilnehmerreaktionen.</a:t>
+              <a:t>Einstiegsfrage: „Wann waren Sie bei einer Neuanlage zuletzt unsicher, ob Sie alles vollständig haben?" Abgrenzung: Was prüft die Sachbearbeitung formal, was klären Berater und Geldwäschebeauftragter inhaltlich?</a:t>
             </a:r>
           </a:p>
         </p:txBody>
@@ -649,7 +657,7 @@
           <a:lstStyle/>
           <a:p>
             <a:r>
-              <a:t>Siehe Trainerhandbuch (Sektion 3) für Moderationshinweise, Timing und erwartete Teilnehmerreaktionen.</a:t>
+              <a:t>Rollen-Abgrenzung aktiv machen: die wirtschaftlich Berechtigten sind VA11-Stoff. Bei der GmbH &amp; Co. KG auf einen VA11-Notizzettel schreiben, nicht in AB-1 eintragen.</a:t>
             </a:r>
           </a:p>
         </p:txBody>
@@ -719,62 +727,7 @@
           <a:lstStyle/>
           <a:p>
             <a:r>
-              <a:t>AB-1 Musterlösung (Trainer-Version)</a:t>
-            </a:r>
-          </a:p>
-          <a:p>
-            <a:r>
-              <a:t>Einzelkaufmann (e.K.): Unterlagen Unternehmen: Gewerbeanmeldung oder HR-Auszug (falls eingetragen). Unterlagen handelnde Person: gültiger Personalausweis oder Reisepass des Inhabers; bei Prokura zusätzlich HR-Auszug mit Prokuraeintrag und Personalausweis des Prokuristen.</a:t>
-            </a:r>
-          </a:p>
-          <a:p>
-            <a:r>
-              <a:t>GbR: Unterlagen Unternehmen: Gesellschaftsvertrag (kein HR-Eintrag). Unterlagen handelnde Personen: Personalausweis aller Gesellschafter, die als Zeichnungsberechtigte auftreten. Achtung: Ohne Gesellschaftsvertrag ist die Vertretungsregelung unklar – im Zweifel alle Gesellschafter zeichnen lassen.</a:t>
-            </a:r>
-          </a:p>
-          <a:p>
-            <a:r>
-              <a:t>GmbH: Unterlagen Unternehmen: aktueller HR-Auszug (enthält GF, Vertretungsregelung). Unterlagen handelnde Person: Personalausweis des/der Geschäftsführer, ggf. Prokuristen. Gesellschaftsvertrag im Regelfall nicht erforderlich (HR-Eintrag ist maßgeblich).</a:t>
-            </a:r>
-          </a:p>
-          <a:p>
-            <a:r>
-              <a:t>GmbH &amp; Co. KG: Unterlagen Unternehmen: HR-Auszug der KG + HR-Auszug der Komplementär-GmbH + ggf. Gesellschaftsvertrag der KG. Unterlagen handelnde Person: Personalausweis des Geschäftsführers der Komplementär-GmbH; bei Kommanditisten-Identifizierung nach GwG ggf. weitere Ausweise. Höchster Prüfaufwand wegen der Doppelstruktur (zwei Register, zwei Gesellschaften).</a:t>
-            </a:r>
-          </a:p>
-          <a:p>
-            <a:r>
-              <a:t>Trainer-Hinweis: Die Musterlösung zeigt das Regelfall-Mindestrepertoire. Hausindividuelle Anforderungen (z. B. intern vorgeschriebene Formulare, Erweiterungen durch GwG-Richtlinien) gehen vor. Den Teilnehmern klarmachen: Das Prinzip ist überall gleich – die Checkliste (AB-5) ist das Werkzeug, das hausindividuelle Ergänzungen verträgt.</a:t>
-            </a:r>
-          </a:p>
-          <a:p>
-            <a:r>
-              <a:t>AB-2 Musterlösung (Trainer-Version)</a:t>
-            </a:r>
-          </a:p>
-          <a:p>
-            <a:r>
-              <a:t>1. Herr Weber allein: Nein – Gesamtvertretung, er benötigt einen zweiten Gesamtvertreter oder einen Prokuristen.</a:t>
-            </a:r>
-          </a:p>
-          <a:p>
-            <a:r>
-              <a:t>2. Herr Kern allein: Nein – Prokuristen können allein handeln (Einzelprokura laut HR), aber Grundstücksgeschäfte sind ausgenommen. Für Kreditverträge ohne Grundstücksbezug: Ja, wenn Einzelprokura eingetragen.</a:t>
-            </a:r>
-          </a:p>
-          <a:p>
-            <a:r>
-              <a:t>3. Rechtswirksame Kombinationen: Weber + Bauer; Weber + Kern (ppa.); Bauer + Kern (ppa.); Kern allein (ppa., für Nichtgrundstücksgeschäfte).</a:t>
-            </a:r>
-          </a:p>
-          <a:p>
-            <a:r>
-              <a:t>4. Abzugleichen: (a) Ist der Unterzeichner im aktuellen HR-Auszug eingetragen? (b) Ist die Vertretungsregelung (Einzel/Gesamt) eingehalten? (c) Ist bei Prokura „ppa." auf dem Dokument vermerkt?</a:t>
-            </a:r>
-          </a:p>
-          <a:p>
-            <a:r>
-              <a:t>Trainer-Hinweis: Häufige Verwechslung: Prokuristen werden oft als „fast wie Geschäftsführer" wahrgenommen. Klarstellen: Ein Prokurist darf sehr viel – aber er darf Grundstücke nicht veräußern oder belasten, sofern ihm diese Befugnis nicht besonders erteilt wurde (§ 49 Abs. 2 HGB). Das ist für Grundschuldbestellungen der zentrale Prüfpunkt: Die erweiterte Befugnis (sog. Immobiliarprokura) muss im Handelsregister eingetragen sein, um gegenüber der Bank zu wirken – nicht notariell beurkundet. Steht sie nicht im HR-Auszug, muss der Geschäft</a:t>
+              <a:t>Pflicht am Flipchart: die Vertretungskette der GmbH &amp; Co. KG skizzieren (KG → Komplementär-GmbH → GF). Einzel- vs. Gesamtvertretung ist der Kernbefund im Fall.</a:t>
             </a:r>
           </a:p>
         </p:txBody>
@@ -844,7 +797,297 @@
           <a:lstStyle/>
           <a:p>
             <a:r>
-              <a:t>Siehe Trainerhandbuch (Sektion 3) für Moderationshinweise, Timing und erwartete Teilnehmerreaktionen.</a:t>
+              <a:t>Kernbefunde: Gesamtvertretung + Prokura, häufiger Fehler fehlender ppa.-Zusatz. Wenn TN auf die Kommanditistin stoßen: das ist VA11 (wirtschaftlich Berechtigter), hier nur notieren.</a:t>
+            </a:r>
+          </a:p>
+        </p:txBody>
+      </p:sp>
+      <p:sp>
+        <p:nvSpPr>
+          <p:cNvPr id="4" name="Slide Number Placeholder 3"/>
+          <p:cNvSpPr>
+            <a:spLocks noGrp="1"/>
+          </p:cNvSpPr>
+          <p:nvPr>
+            <p:ph type="sldNum" idx="5" sz="quarter"/>
+          </p:nvPr>
+        </p:nvSpPr>
+        <p:spPr/>
+      </p:sp>
+    </p:spTree>
+  </p:cSld>
+  <p:clrMapOvr>
+    <a:masterClrMapping/>
+  </p:clrMapOvr>
+</p:notes>
+</file>
+
+<file path=ppt/notesSlides/notesSlide6.xml><?xml version="1.0" encoding="utf-8"?>
+<p:notes xmlns:a="http://schemas.openxmlformats.org/drawingml/2006/main" xmlns:p="http://schemas.openxmlformats.org/presentationml/2006/main" xmlns:r="http://schemas.openxmlformats.org/officeDocument/2006/relationships">
+  <p:cSld>
+    <p:spTree>
+      <p:nvGrpSpPr>
+        <p:cNvPr id="1" name=""/>
+        <p:cNvGrpSpPr/>
+        <p:nvPr/>
+      </p:nvGrpSpPr>
+      <p:grpSpPr>
+        <a:xfrm>
+          <a:off x="0" y="0"/>
+          <a:ext cx="0" cy="0"/>
+          <a:chOff x="0" y="0"/>
+          <a:chExt cx="0" cy="0"/>
+        </a:xfrm>
+      </p:grpSpPr>
+      <p:sp>
+        <p:nvSpPr>
+          <p:cNvPr id="2" name="Slide Image Placeholder 1"/>
+          <p:cNvSpPr>
+            <a:spLocks noGrp="1"/>
+          </p:cNvSpPr>
+          <p:nvPr>
+            <p:ph type="sldImg" idx="2"/>
+          </p:nvPr>
+        </p:nvSpPr>
+        <p:spPr/>
+      </p:sp>
+      <p:sp>
+        <p:nvSpPr>
+          <p:cNvPr id="3" name="Notes Placeholder 2"/>
+          <p:cNvSpPr>
+            <a:spLocks noGrp="1"/>
+          </p:cNvSpPr>
+          <p:nvPr>
+            <p:ph type="body" idx="3" sz="quarter"/>
+          </p:nvPr>
+        </p:nvSpPr>
+        <p:spPr/>
+        <p:txBody>
+          <a:bodyPr/>
+          <a:lstStyle/>
+          <a:p>
+            <a:r>
+              <a:t>Ein Dokument mit fehlender zweiter Unterschrift bei Gesamtvertretung ist nicht rechtswirksam. Eskalation an den Berater ist Pflicht, keine Ermessensfrage.</a:t>
+            </a:r>
+          </a:p>
+        </p:txBody>
+      </p:sp>
+      <p:sp>
+        <p:nvSpPr>
+          <p:cNvPr id="4" name="Slide Number Placeholder 3"/>
+          <p:cNvSpPr>
+            <a:spLocks noGrp="1"/>
+          </p:cNvSpPr>
+          <p:nvPr>
+            <p:ph type="sldNum" idx="5" sz="quarter"/>
+          </p:nvPr>
+        </p:nvSpPr>
+        <p:spPr/>
+      </p:sp>
+    </p:spTree>
+  </p:cSld>
+  <p:clrMapOvr>
+    <a:masterClrMapping/>
+  </p:clrMapOvr>
+</p:notes>
+</file>
+
+<file path=ppt/notesSlides/notesSlide7.xml><?xml version="1.0" encoding="utf-8"?>
+<p:notes xmlns:a="http://schemas.openxmlformats.org/drawingml/2006/main" xmlns:p="http://schemas.openxmlformats.org/presentationml/2006/main" xmlns:r="http://schemas.openxmlformats.org/officeDocument/2006/relationships">
+  <p:cSld>
+    <p:spTree>
+      <p:nvGrpSpPr>
+        <p:cNvPr id="1" name=""/>
+        <p:cNvGrpSpPr/>
+        <p:nvPr/>
+      </p:nvGrpSpPr>
+      <p:grpSpPr>
+        <a:xfrm>
+          <a:off x="0" y="0"/>
+          <a:ext cx="0" cy="0"/>
+          <a:chOff x="0" y="0"/>
+          <a:chExt cx="0" cy="0"/>
+        </a:xfrm>
+      </p:grpSpPr>
+      <p:sp>
+        <p:nvSpPr>
+          <p:cNvPr id="2" name="Slide Image Placeholder 1"/>
+          <p:cNvSpPr>
+            <a:spLocks noGrp="1"/>
+          </p:cNvSpPr>
+          <p:nvPr>
+            <p:ph type="sldImg" idx="2"/>
+          </p:nvPr>
+        </p:nvSpPr>
+        <p:spPr/>
+      </p:sp>
+      <p:sp>
+        <p:nvSpPr>
+          <p:cNvPr id="3" name="Notes Placeholder 2"/>
+          <p:cNvSpPr>
+            <a:spLocks noGrp="1"/>
+          </p:cNvSpPr>
+          <p:nvPr>
+            <p:ph type="body" idx="3" sz="quarter"/>
+          </p:nvPr>
+        </p:nvSpPr>
+        <p:spPr/>
+        <p:txBody>
+          <a:bodyPr/>
+          <a:lstStyle/>
+          <a:p>
+            <a:r>
+              <a:t>AB-2 Musterlösung (Trainer-Version)</a:t>
+            </a:r>
+          </a:p>
+          <a:p>
+            <a:r>
+              <a:t>Kernbefunde: Gesamtvertretung laut HR + Prokura (ppa.). Häufiger Fehler: fehlender ppa.-Zusatz auf der Vertragsunterlage.</a:t>
+            </a:r>
+          </a:p>
+          <a:p>
+            <a:r>
+              <a:t>Trainer-Hinweis: die Kommanditistin gehört zur VA11-Frage (wirtschaftlich Berechtigter), nicht in die formale Legitimationsprüfung von VA10.</a:t>
+            </a:r>
+          </a:p>
+        </p:txBody>
+      </p:sp>
+      <p:sp>
+        <p:nvSpPr>
+          <p:cNvPr id="4" name="Slide Number Placeholder 3"/>
+          <p:cNvSpPr>
+            <a:spLocks noGrp="1"/>
+          </p:cNvSpPr>
+          <p:nvPr>
+            <p:ph type="sldNum" idx="5" sz="quarter"/>
+          </p:nvPr>
+        </p:nvSpPr>
+        <p:spPr/>
+      </p:sp>
+    </p:spTree>
+  </p:cSld>
+  <p:clrMapOvr>
+    <a:masterClrMapping/>
+  </p:clrMapOvr>
+</p:notes>
+</file>
+
+<file path=ppt/notesSlides/notesSlide8.xml><?xml version="1.0" encoding="utf-8"?>
+<p:notes xmlns:a="http://schemas.openxmlformats.org/drawingml/2006/main" xmlns:p="http://schemas.openxmlformats.org/presentationml/2006/main" xmlns:r="http://schemas.openxmlformats.org/officeDocument/2006/relationships">
+  <p:cSld>
+    <p:spTree>
+      <p:nvGrpSpPr>
+        <p:cNvPr id="1" name=""/>
+        <p:cNvGrpSpPr/>
+        <p:nvPr/>
+      </p:nvGrpSpPr>
+      <p:grpSpPr>
+        <a:xfrm>
+          <a:off x="0" y="0"/>
+          <a:ext cx="0" cy="0"/>
+          <a:chOff x="0" y="0"/>
+          <a:chExt cx="0" cy="0"/>
+        </a:xfrm>
+      </p:grpSpPr>
+      <p:sp>
+        <p:nvSpPr>
+          <p:cNvPr id="2" name="Slide Image Placeholder 1"/>
+          <p:cNvSpPr>
+            <a:spLocks noGrp="1"/>
+          </p:cNvSpPr>
+          <p:nvPr>
+            <p:ph type="sldImg" idx="2"/>
+          </p:nvPr>
+        </p:nvSpPr>
+        <p:spPr/>
+      </p:sp>
+      <p:sp>
+        <p:nvSpPr>
+          <p:cNvPr id="3" name="Notes Placeholder 2"/>
+          <p:cNvSpPr>
+            <a:spLocks noGrp="1"/>
+          </p:cNvSpPr>
+          <p:nvPr>
+            <p:ph type="body" idx="3" sz="quarter"/>
+          </p:nvPr>
+        </p:nvSpPr>
+        <p:spPr/>
+        <p:txBody>
+          <a:bodyPr/>
+          <a:lstStyle/>
+          <a:p>
+            <a:r>
+              <a:t>Prüfkarte AB-5 als Werkzeug für morgen früh. Ausblick VA11: wirtschaftlich Berechtigter, Kreditnehmereinheit, vertiefte Geldwäscheprävention.</a:t>
+            </a:r>
+          </a:p>
+        </p:txBody>
+      </p:sp>
+      <p:sp>
+        <p:nvSpPr>
+          <p:cNvPr id="4" name="Slide Number Placeholder 3"/>
+          <p:cNvSpPr>
+            <a:spLocks noGrp="1"/>
+          </p:cNvSpPr>
+          <p:nvPr>
+            <p:ph type="sldNum" idx="5" sz="quarter"/>
+          </p:nvPr>
+        </p:nvSpPr>
+        <p:spPr/>
+      </p:sp>
+    </p:spTree>
+  </p:cSld>
+  <p:clrMapOvr>
+    <a:masterClrMapping/>
+  </p:clrMapOvr>
+</p:notes>
+</file>
+
+<file path=ppt/notesSlides/notesSlide9.xml><?xml version="1.0" encoding="utf-8"?>
+<p:notes xmlns:a="http://schemas.openxmlformats.org/drawingml/2006/main" xmlns:p="http://schemas.openxmlformats.org/presentationml/2006/main" xmlns:r="http://schemas.openxmlformats.org/officeDocument/2006/relationships">
+  <p:cSld>
+    <p:spTree>
+      <p:nvGrpSpPr>
+        <p:cNvPr id="1" name=""/>
+        <p:cNvGrpSpPr/>
+        <p:nvPr/>
+      </p:nvGrpSpPr>
+      <p:grpSpPr>
+        <a:xfrm>
+          <a:off x="0" y="0"/>
+          <a:ext cx="0" cy="0"/>
+          <a:chOff x="0" y="0"/>
+          <a:chExt cx="0" cy="0"/>
+        </a:xfrm>
+      </p:grpSpPr>
+      <p:sp>
+        <p:nvSpPr>
+          <p:cNvPr id="2" name="Slide Image Placeholder 1"/>
+          <p:cNvSpPr>
+            <a:spLocks noGrp="1"/>
+          </p:cNvSpPr>
+          <p:nvPr>
+            <p:ph type="sldImg" idx="2"/>
+          </p:nvPr>
+        </p:nvSpPr>
+        <p:spPr/>
+      </p:sp>
+      <p:sp>
+        <p:nvSpPr>
+          <p:cNvPr id="3" name="Notes Placeholder 2"/>
+          <p:cNvSpPr>
+            <a:spLocks noGrp="1"/>
+          </p:cNvSpPr>
+          <p:nvPr>
+            <p:ph type="body" idx="3" sz="quarter"/>
+          </p:nvPr>
+        </p:nvSpPr>
+        <p:spPr/>
+        <p:txBody>
+          <a:bodyPr/>
+          <a:lstStyle/>
+          <a:p>
+            <a:r>
+              <a:t>Eine Reflexionsfrage in der Gruppe besprechen. Prüfkarte AB-5 übergeben.</a:t>
             </a:r>
           </a:p>
         </p:txBody>
@@ -4415,6 +4658,2810 @@
 </p:sld>
 </file>
 
+<file path=ppt/slides/slide10.xml><?xml version="1.0" encoding="utf-8"?>
+<p:sld xmlns:a="http://schemas.openxmlformats.org/drawingml/2006/main" xmlns:p="http://schemas.openxmlformats.org/presentationml/2006/main" xmlns:r="http://schemas.openxmlformats.org/officeDocument/2006/relationships">
+  <p:cSld>
+    <p:spTree>
+      <p:nvGrpSpPr>
+        <p:cNvPr id="1" name=""/>
+        <p:cNvGrpSpPr/>
+        <p:nvPr/>
+      </p:nvGrpSpPr>
+      <p:grpSpPr/>
+      <p:sp>
+        <p:nvSpPr>
+          <p:cNvPr id="2" name="Rectangle 1"/>
+          <p:cNvSpPr/>
+          <p:nvPr/>
+        </p:nvSpPr>
+        <p:spPr>
+          <a:xfrm>
+            <a:off x="0" y="0"/>
+            <a:ext cx="12188952" cy="6858000"/>
+          </a:xfrm>
+          <a:prstGeom prst="rect">
+            <a:avLst/>
+          </a:prstGeom>
+          <a:solidFill>
+            <a:srgbClr val="FFFFFF"/>
+          </a:solidFill>
+          <a:ln>
+            <a:noFill/>
+          </a:ln>
+        </p:spPr>
+        <p:style>
+          <a:lnRef idx="1">
+            <a:schemeClr val="accent1"/>
+          </a:lnRef>
+          <a:fillRef idx="3">
+            <a:schemeClr val="accent1"/>
+          </a:fillRef>
+          <a:effectRef idx="2">
+            <a:schemeClr val="accent1"/>
+          </a:effectRef>
+          <a:fontRef idx="minor">
+            <a:schemeClr val="lt1"/>
+          </a:fontRef>
+        </p:style>
+        <p:txBody>
+          <a:bodyPr rtlCol="0" anchor="ctr"/>
+          <a:lstStyle/>
+          <a:p>
+            <a:pPr algn="ctr"/>
+          </a:p>
+        </p:txBody>
+      </p:sp>
+      <p:sp>
+        <p:nvSpPr>
+          <p:cNvPr id="3" name="Rectangle 2"/>
+          <p:cNvSpPr/>
+          <p:nvPr/>
+        </p:nvSpPr>
+        <p:spPr>
+          <a:xfrm>
+            <a:off x="0" y="0"/>
+            <a:ext cx="12188952" cy="50292"/>
+          </a:xfrm>
+          <a:prstGeom prst="rect">
+            <a:avLst/>
+          </a:prstGeom>
+          <a:solidFill>
+            <a:srgbClr val="1F2C56"/>
+          </a:solidFill>
+          <a:ln>
+            <a:noFill/>
+          </a:ln>
+        </p:spPr>
+        <p:style>
+          <a:lnRef idx="1">
+            <a:schemeClr val="accent1"/>
+          </a:lnRef>
+          <a:fillRef idx="3">
+            <a:schemeClr val="accent1"/>
+          </a:fillRef>
+          <a:effectRef idx="2">
+            <a:schemeClr val="accent1"/>
+          </a:effectRef>
+          <a:fontRef idx="minor">
+            <a:schemeClr val="lt1"/>
+          </a:fontRef>
+        </p:style>
+        <p:txBody>
+          <a:bodyPr rtlCol="0" anchor="ctr"/>
+          <a:lstStyle/>
+          <a:p>
+            <a:pPr algn="ctr"/>
+          </a:p>
+        </p:txBody>
+      </p:sp>
+      <p:sp>
+        <p:nvSpPr>
+          <p:cNvPr id="4" name="TextBox 3"/>
+          <p:cNvSpPr txBox="1"/>
+          <p:nvPr/>
+        </p:nvSpPr>
+        <p:spPr>
+          <a:xfrm>
+            <a:off x="685800" y="109728"/>
+            <a:ext cx="10817352" cy="228600"/>
+          </a:xfrm>
+          <a:prstGeom prst="rect">
+            <a:avLst/>
+          </a:prstGeom>
+          <a:noFill/>
+        </p:spPr>
+        <p:txBody>
+          <a:bodyPr wrap="none">
+            <a:spAutoFit/>
+          </a:bodyPr>
+          <a:lstStyle/>
+          <a:p>
+            <a:pPr algn="l"/>
+            <a:r>
+              <a:rPr sz="750">
+                <a:solidFill>
+                  <a:srgbClr val="78808C"/>
+                </a:solidFill>
+                <a:latin typeface="Consolas"/>
+              </a:rPr>
+              <a:t>VA10  ·  SCHAUBILD</a:t>
+            </a:r>
+          </a:p>
+        </p:txBody>
+      </p:sp>
+      <p:sp>
+        <p:nvSpPr>
+          <p:cNvPr id="5" name="TextBox 4"/>
+          <p:cNvSpPr txBox="1"/>
+          <p:nvPr/>
+        </p:nvSpPr>
+        <p:spPr>
+          <a:xfrm>
+            <a:off x="685800" y="502920"/>
+            <a:ext cx="10817352" cy="594360"/>
+          </a:xfrm>
+          <a:prstGeom prst="rect">
+            <a:avLst/>
+          </a:prstGeom>
+          <a:noFill/>
+        </p:spPr>
+        <p:txBody>
+          <a:bodyPr wrap="square">
+            <a:spAutoFit/>
+          </a:bodyPr>
+          <a:lstStyle/>
+          <a:p>
+            <a:pPr algn="l"/>
+            <a:r>
+              <a:rPr sz="2000" b="1" i="0">
+                <a:solidFill>
+                  <a:srgbClr val="1F2C56"/>
+                </a:solidFill>
+                <a:latin typeface="Arial"/>
+              </a:rPr>
+              <a:t>Vertretung nach Rechtsform</a:t>
+            </a:r>
+          </a:p>
+        </p:txBody>
+      </p:sp>
+      <p:sp>
+        <p:nvSpPr>
+          <p:cNvPr id="6" name="Rectangle 5"/>
+          <p:cNvSpPr/>
+          <p:nvPr/>
+        </p:nvSpPr>
+        <p:spPr>
+          <a:xfrm>
+            <a:off x="685800" y="1143000"/>
+            <a:ext cx="10817352" cy="25400"/>
+          </a:xfrm>
+          <a:prstGeom prst="rect">
+            <a:avLst/>
+          </a:prstGeom>
+          <a:solidFill>
+            <a:srgbClr val="D9C089"/>
+          </a:solidFill>
+          <a:ln>
+            <a:noFill/>
+          </a:ln>
+        </p:spPr>
+        <p:style>
+          <a:lnRef idx="1">
+            <a:schemeClr val="accent1"/>
+          </a:lnRef>
+          <a:fillRef idx="3">
+            <a:schemeClr val="accent1"/>
+          </a:fillRef>
+          <a:effectRef idx="2">
+            <a:schemeClr val="accent1"/>
+          </a:effectRef>
+          <a:fontRef idx="minor">
+            <a:schemeClr val="lt1"/>
+          </a:fontRef>
+        </p:style>
+        <p:txBody>
+          <a:bodyPr rtlCol="0" anchor="ctr"/>
+          <a:lstStyle/>
+          <a:p>
+            <a:pPr algn="ctr"/>
+          </a:p>
+        </p:txBody>
+      </p:sp>
+      <p:pic>
+        <p:nvPicPr>
+          <p:cNvPr id="7" name="Picture 6" descr="image.png"/>
+          <p:cNvPicPr>
+            <a:picLocks noChangeAspect="1"/>
+          </p:cNvPicPr>
+          <p:nvPr/>
+        </p:nvPicPr>
+        <p:blipFill>
+          <a:blip r:embed="rId2"/>
+          <a:stretch>
+            <a:fillRect/>
+          </a:stretch>
+        </p:blipFill>
+        <p:spPr>
+          <a:xfrm>
+            <a:off x="2303489" y="1325880"/>
+            <a:ext cx="7581973" cy="4937760"/>
+          </a:xfrm>
+          <a:prstGeom prst="rect">
+            <a:avLst/>
+          </a:prstGeom>
+        </p:spPr>
+      </p:pic>
+      <p:sp>
+        <p:nvSpPr>
+          <p:cNvPr id="8" name="Rectangle 7"/>
+          <p:cNvSpPr/>
+          <p:nvPr/>
+        </p:nvSpPr>
+        <p:spPr>
+          <a:xfrm>
+            <a:off x="0" y="6510528"/>
+            <a:ext cx="12188952" cy="347472"/>
+          </a:xfrm>
+          <a:prstGeom prst="rect">
+            <a:avLst/>
+          </a:prstGeom>
+          <a:solidFill>
+            <a:srgbClr val="0A1937"/>
+          </a:solidFill>
+          <a:ln>
+            <a:noFill/>
+          </a:ln>
+        </p:spPr>
+        <p:style>
+          <a:lnRef idx="1">
+            <a:schemeClr val="accent1"/>
+          </a:lnRef>
+          <a:fillRef idx="3">
+            <a:schemeClr val="accent1"/>
+          </a:fillRef>
+          <a:effectRef idx="2">
+            <a:schemeClr val="accent1"/>
+          </a:effectRef>
+          <a:fontRef idx="minor">
+            <a:schemeClr val="lt1"/>
+          </a:fontRef>
+        </p:style>
+        <p:txBody>
+          <a:bodyPr rtlCol="0" anchor="ctr"/>
+          <a:lstStyle/>
+          <a:p>
+            <a:pPr algn="ctr"/>
+          </a:p>
+        </p:txBody>
+      </p:sp>
+      <p:sp>
+        <p:nvSpPr>
+          <p:cNvPr id="9" name="TextBox 8"/>
+          <p:cNvSpPr txBox="1"/>
+          <p:nvPr/>
+        </p:nvSpPr>
+        <p:spPr>
+          <a:xfrm>
+            <a:off x="685800" y="6583680"/>
+            <a:ext cx="6490411" cy="256032"/>
+          </a:xfrm>
+          <a:prstGeom prst="rect">
+            <a:avLst/>
+          </a:prstGeom>
+          <a:noFill/>
+        </p:spPr>
+        <p:txBody>
+          <a:bodyPr wrap="none">
+            <a:spAutoFit/>
+          </a:bodyPr>
+          <a:lstStyle/>
+          <a:p>
+            <a:pPr algn="l"/>
+            <a:r>
+              <a:rPr sz="700">
+                <a:solidFill>
+                  <a:srgbClr val="A0B4D2"/>
+                </a:solidFill>
+                <a:latin typeface="Consolas"/>
+              </a:rPr>
+              <a:t>FKB Campus  ·  VA10</a:t>
+            </a:r>
+          </a:p>
+        </p:txBody>
+      </p:sp>
+      <p:sp>
+        <p:nvSpPr>
+          <p:cNvPr id="10" name="TextBox 9"/>
+          <p:cNvSpPr txBox="1"/>
+          <p:nvPr/>
+        </p:nvSpPr>
+        <p:spPr>
+          <a:xfrm>
+            <a:off x="7176211" y="6583680"/>
+            <a:ext cx="4326940" cy="256032"/>
+          </a:xfrm>
+          <a:prstGeom prst="rect">
+            <a:avLst/>
+          </a:prstGeom>
+          <a:noFill/>
+        </p:spPr>
+        <p:txBody>
+          <a:bodyPr wrap="none">
+            <a:spAutoFit/>
+          </a:bodyPr>
+          <a:lstStyle/>
+          <a:p>
+            <a:pPr algn="r"/>
+            <a:r>
+              <a:rPr sz="700">
+                <a:solidFill>
+                  <a:srgbClr val="A0B4D2"/>
+                </a:solidFill>
+                <a:latin typeface="Consolas"/>
+              </a:rPr>
+              <a:t>Schaubild</a:t>
+            </a:r>
+          </a:p>
+        </p:txBody>
+      </p:sp>
+    </p:spTree>
+  </p:cSld>
+  <p:clrMapOvr>
+    <a:masterClrMapping/>
+  </p:clrMapOvr>
+</p:sld>
+</file>
+
+<file path=ppt/slides/slide11.xml><?xml version="1.0" encoding="utf-8"?>
+<p:sld xmlns:a="http://schemas.openxmlformats.org/drawingml/2006/main" xmlns:p="http://schemas.openxmlformats.org/presentationml/2006/main" xmlns:r="http://schemas.openxmlformats.org/officeDocument/2006/relationships">
+  <p:cSld>
+    <p:spTree>
+      <p:nvGrpSpPr>
+        <p:cNvPr id="1" name=""/>
+        <p:cNvGrpSpPr/>
+        <p:nvPr/>
+      </p:nvGrpSpPr>
+      <p:grpSpPr/>
+      <p:sp>
+        <p:nvSpPr>
+          <p:cNvPr id="2" name="Rectangle 1"/>
+          <p:cNvSpPr/>
+          <p:nvPr/>
+        </p:nvSpPr>
+        <p:spPr>
+          <a:xfrm>
+            <a:off x="0" y="0"/>
+            <a:ext cx="12188952" cy="6858000"/>
+          </a:xfrm>
+          <a:prstGeom prst="rect">
+            <a:avLst/>
+          </a:prstGeom>
+          <a:solidFill>
+            <a:srgbClr val="1F2C56"/>
+          </a:solidFill>
+          <a:ln>
+            <a:noFill/>
+          </a:ln>
+        </p:spPr>
+        <p:style>
+          <a:lnRef idx="1">
+            <a:schemeClr val="accent1"/>
+          </a:lnRef>
+          <a:fillRef idx="3">
+            <a:schemeClr val="accent1"/>
+          </a:fillRef>
+          <a:effectRef idx="2">
+            <a:schemeClr val="accent1"/>
+          </a:effectRef>
+          <a:fontRef idx="minor">
+            <a:schemeClr val="lt1"/>
+          </a:fontRef>
+        </p:style>
+        <p:txBody>
+          <a:bodyPr rtlCol="0" anchor="ctr"/>
+          <a:lstStyle/>
+          <a:p>
+            <a:pPr algn="ctr"/>
+          </a:p>
+        </p:txBody>
+      </p:sp>
+      <p:sp>
+        <p:nvSpPr>
+          <p:cNvPr id="3" name="TextBox 2"/>
+          <p:cNvSpPr txBox="1"/>
+          <p:nvPr/>
+        </p:nvSpPr>
+        <p:spPr>
+          <a:xfrm>
+            <a:off x="685800" y="2377440"/>
+            <a:ext cx="10817352" cy="365760"/>
+          </a:xfrm>
+          <a:prstGeom prst="rect">
+            <a:avLst/>
+          </a:prstGeom>
+          <a:noFill/>
+        </p:spPr>
+        <p:txBody>
+          <a:bodyPr wrap="none">
+            <a:spAutoFit/>
+          </a:bodyPr>
+          <a:lstStyle/>
+          <a:p>
+            <a:pPr algn="l"/>
+            <a:r>
+              <a:rPr sz="1200">
+                <a:solidFill>
+                  <a:srgbClr val="D9C089"/>
+                </a:solidFill>
+                <a:latin typeface="Consolas"/>
+              </a:rPr>
+              <a:t>00:35–01:20</a:t>
+            </a:r>
+          </a:p>
+        </p:txBody>
+      </p:sp>
+      <p:sp>
+        <p:nvSpPr>
+          <p:cNvPr id="4" name="Rectangle 3"/>
+          <p:cNvSpPr/>
+          <p:nvPr/>
+        </p:nvSpPr>
+        <p:spPr>
+          <a:xfrm>
+            <a:off x="685800" y="2788920"/>
+            <a:ext cx="548640" cy="38100"/>
+          </a:xfrm>
+          <a:prstGeom prst="rect">
+            <a:avLst/>
+          </a:prstGeom>
+          <a:solidFill>
+            <a:srgbClr val="D9C089"/>
+          </a:solidFill>
+          <a:ln>
+            <a:noFill/>
+          </a:ln>
+        </p:spPr>
+        <p:style>
+          <a:lnRef idx="1">
+            <a:schemeClr val="accent1"/>
+          </a:lnRef>
+          <a:fillRef idx="3">
+            <a:schemeClr val="accent1"/>
+          </a:fillRef>
+          <a:effectRef idx="2">
+            <a:schemeClr val="accent1"/>
+          </a:effectRef>
+          <a:fontRef idx="minor">
+            <a:schemeClr val="lt1"/>
+          </a:fontRef>
+        </p:style>
+        <p:txBody>
+          <a:bodyPr rtlCol="0" anchor="ctr"/>
+          <a:lstStyle/>
+          <a:p>
+            <a:pPr algn="ctr"/>
+          </a:p>
+        </p:txBody>
+      </p:sp>
+      <p:sp>
+        <p:nvSpPr>
+          <p:cNvPr id="5" name="TextBox 4"/>
+          <p:cNvSpPr txBox="1"/>
+          <p:nvPr/>
+        </p:nvSpPr>
+        <p:spPr>
+          <a:xfrm>
+            <a:off x="685800" y="3017520"/>
+            <a:ext cx="10817352" cy="1463040"/>
+          </a:xfrm>
+          <a:prstGeom prst="rect">
+            <a:avLst/>
+          </a:prstGeom>
+          <a:noFill/>
+        </p:spPr>
+        <p:txBody>
+          <a:bodyPr wrap="square">
+            <a:spAutoFit/>
+          </a:bodyPr>
+          <a:lstStyle/>
+          <a:p>
+            <a:pPr algn="l"/>
+            <a:r>
+              <a:rPr sz="4000" b="1" i="0">
+                <a:solidFill>
+                  <a:srgbClr val="FFFFFF"/>
+                </a:solidFill>
+                <a:latin typeface="Arial"/>
+              </a:rPr>
+              <a:t>Fallübergabe &amp; Fallarbeit</a:t>
+            </a:r>
+          </a:p>
+        </p:txBody>
+      </p:sp>
+      <p:sp>
+        <p:nvSpPr>
+          <p:cNvPr id="6" name="TextBox 5"/>
+          <p:cNvSpPr txBox="1"/>
+          <p:nvPr/>
+        </p:nvSpPr>
+        <p:spPr>
+          <a:xfrm>
+            <a:off x="685800" y="4480560"/>
+            <a:ext cx="8653881" cy="1280160"/>
+          </a:xfrm>
+          <a:prstGeom prst="rect">
+            <a:avLst/>
+          </a:prstGeom>
+          <a:noFill/>
+        </p:spPr>
+        <p:txBody>
+          <a:bodyPr wrap="square">
+            <a:spAutoFit/>
+          </a:bodyPr>
+          <a:lstStyle/>
+          <a:p>
+            <a:pPr algn="l"/>
+            <a:r>
+              <a:rPr sz="1600" b="0" i="0">
+                <a:solidFill>
+                  <a:srgbClr val="C8D2E6"/>
+                </a:solidFill>
+                <a:latin typeface="Arial"/>
+              </a:rPr>
+              <a:t>Tischler-Meistermarkt GmbH &amp; Co. KG anlegen – oder gibt es Probleme?</a:t>
+            </a:r>
+          </a:p>
+        </p:txBody>
+      </p:sp>
+      <p:sp>
+        <p:nvSpPr>
+          <p:cNvPr id="7" name="TextBox 6"/>
+          <p:cNvSpPr txBox="1"/>
+          <p:nvPr/>
+        </p:nvSpPr>
+        <p:spPr>
+          <a:xfrm>
+            <a:off x="685800" y="6355080"/>
+            <a:ext cx="10817352" cy="274320"/>
+          </a:xfrm>
+          <a:prstGeom prst="rect">
+            <a:avLst/>
+          </a:prstGeom>
+          <a:noFill/>
+        </p:spPr>
+        <p:txBody>
+          <a:bodyPr wrap="none">
+            <a:spAutoFit/>
+          </a:bodyPr>
+          <a:lstStyle/>
+          <a:p>
+            <a:pPr algn="l"/>
+            <a:r>
+              <a:rPr sz="700">
+                <a:solidFill>
+                  <a:srgbClr val="8CA0C3"/>
+                </a:solidFill>
+                <a:latin typeface="Consolas"/>
+              </a:rPr>
+              <a:t>FKB Campus  ·  VA10</a:t>
+            </a:r>
+          </a:p>
+        </p:txBody>
+      </p:sp>
+    </p:spTree>
+  </p:cSld>
+  <p:clrMapOvr>
+    <a:masterClrMapping/>
+  </p:clrMapOvr>
+</p:sld>
+</file>
+
+<file path=ppt/slides/slide12.xml><?xml version="1.0" encoding="utf-8"?>
+<p:sld xmlns:a="http://schemas.openxmlformats.org/drawingml/2006/main" xmlns:p="http://schemas.openxmlformats.org/presentationml/2006/main" xmlns:r="http://schemas.openxmlformats.org/officeDocument/2006/relationships">
+  <p:cSld>
+    <p:spTree>
+      <p:nvGrpSpPr>
+        <p:cNvPr id="1" name=""/>
+        <p:cNvGrpSpPr/>
+        <p:nvPr/>
+      </p:nvGrpSpPr>
+      <p:grpSpPr/>
+      <p:sp>
+        <p:nvSpPr>
+          <p:cNvPr id="2" name="Rectangle 1"/>
+          <p:cNvSpPr/>
+          <p:nvPr/>
+        </p:nvSpPr>
+        <p:spPr>
+          <a:xfrm>
+            <a:off x="0" y="0"/>
+            <a:ext cx="12188952" cy="6858000"/>
+          </a:xfrm>
+          <a:prstGeom prst="rect">
+            <a:avLst/>
+          </a:prstGeom>
+          <a:solidFill>
+            <a:srgbClr val="EDEDF3"/>
+          </a:solidFill>
+          <a:ln>
+            <a:noFill/>
+          </a:ln>
+        </p:spPr>
+        <p:style>
+          <a:lnRef idx="1">
+            <a:schemeClr val="accent1"/>
+          </a:lnRef>
+          <a:fillRef idx="3">
+            <a:schemeClr val="accent1"/>
+          </a:fillRef>
+          <a:effectRef idx="2">
+            <a:schemeClr val="accent1"/>
+          </a:effectRef>
+          <a:fontRef idx="minor">
+            <a:schemeClr val="lt1"/>
+          </a:fontRef>
+        </p:style>
+        <p:txBody>
+          <a:bodyPr rtlCol="0" anchor="ctr"/>
+          <a:lstStyle/>
+          <a:p>
+            <a:pPr algn="ctr"/>
+          </a:p>
+        </p:txBody>
+      </p:sp>
+      <p:sp>
+        <p:nvSpPr>
+          <p:cNvPr id="3" name="Rectangle 2"/>
+          <p:cNvSpPr/>
+          <p:nvPr/>
+        </p:nvSpPr>
+        <p:spPr>
+          <a:xfrm>
+            <a:off x="0" y="0"/>
+            <a:ext cx="12188952" cy="50292"/>
+          </a:xfrm>
+          <a:prstGeom prst="rect">
+            <a:avLst/>
+          </a:prstGeom>
+          <a:solidFill>
+            <a:srgbClr val="1F2C56"/>
+          </a:solidFill>
+          <a:ln>
+            <a:noFill/>
+          </a:ln>
+        </p:spPr>
+        <p:style>
+          <a:lnRef idx="1">
+            <a:schemeClr val="accent1"/>
+          </a:lnRef>
+          <a:fillRef idx="3">
+            <a:schemeClr val="accent1"/>
+          </a:fillRef>
+          <a:effectRef idx="2">
+            <a:schemeClr val="accent1"/>
+          </a:effectRef>
+          <a:fontRef idx="minor">
+            <a:schemeClr val="lt1"/>
+          </a:fontRef>
+        </p:style>
+        <p:txBody>
+          <a:bodyPr rtlCol="0" anchor="ctr"/>
+          <a:lstStyle/>
+          <a:p>
+            <a:pPr algn="ctr"/>
+          </a:p>
+        </p:txBody>
+      </p:sp>
+      <p:sp>
+        <p:nvSpPr>
+          <p:cNvPr id="4" name="TextBox 3"/>
+          <p:cNvSpPr txBox="1"/>
+          <p:nvPr/>
+        </p:nvSpPr>
+        <p:spPr>
+          <a:xfrm>
+            <a:off x="685800" y="109728"/>
+            <a:ext cx="10817352" cy="228600"/>
+          </a:xfrm>
+          <a:prstGeom prst="rect">
+            <a:avLst/>
+          </a:prstGeom>
+          <a:noFill/>
+        </p:spPr>
+        <p:txBody>
+          <a:bodyPr wrap="none">
+            <a:spAutoFit/>
+          </a:bodyPr>
+          <a:lstStyle/>
+          <a:p>
+            <a:pPr algn="l"/>
+            <a:r>
+              <a:rPr sz="750">
+                <a:solidFill>
+                  <a:srgbClr val="78808C"/>
+                </a:solidFill>
+                <a:latin typeface="Consolas"/>
+              </a:rPr>
+              <a:t>VA10  ·  INHALT</a:t>
+            </a:r>
+          </a:p>
+        </p:txBody>
+      </p:sp>
+      <p:sp>
+        <p:nvSpPr>
+          <p:cNvPr id="5" name="Rectangle 4"/>
+          <p:cNvSpPr/>
+          <p:nvPr/>
+        </p:nvSpPr>
+        <p:spPr>
+          <a:xfrm>
+            <a:off x="0" y="1234440"/>
+            <a:ext cx="12188952" cy="12700"/>
+          </a:xfrm>
+          <a:prstGeom prst="rect">
+            <a:avLst/>
+          </a:prstGeom>
+          <a:solidFill>
+            <a:srgbClr val="D8DFE4"/>
+          </a:solidFill>
+          <a:ln>
+            <a:noFill/>
+          </a:ln>
+        </p:spPr>
+        <p:style>
+          <a:lnRef idx="1">
+            <a:schemeClr val="accent1"/>
+          </a:lnRef>
+          <a:fillRef idx="3">
+            <a:schemeClr val="accent1"/>
+          </a:fillRef>
+          <a:effectRef idx="2">
+            <a:schemeClr val="accent1"/>
+          </a:effectRef>
+          <a:fontRef idx="minor">
+            <a:schemeClr val="lt1"/>
+          </a:fontRef>
+        </p:style>
+        <p:txBody>
+          <a:bodyPr rtlCol="0" anchor="ctr"/>
+          <a:lstStyle/>
+          <a:p>
+            <a:pPr algn="ctr"/>
+          </a:p>
+        </p:txBody>
+      </p:sp>
+      <p:sp>
+        <p:nvSpPr>
+          <p:cNvPr id="6" name="Rectangle 5"/>
+          <p:cNvSpPr/>
+          <p:nvPr/>
+        </p:nvSpPr>
+        <p:spPr>
+          <a:xfrm>
+            <a:off x="685800" y="502920"/>
+            <a:ext cx="36576" cy="658368"/>
+          </a:xfrm>
+          <a:prstGeom prst="rect">
+            <a:avLst/>
+          </a:prstGeom>
+          <a:solidFill>
+            <a:srgbClr val="D9C089"/>
+          </a:solidFill>
+          <a:ln>
+            <a:noFill/>
+          </a:ln>
+        </p:spPr>
+        <p:style>
+          <a:lnRef idx="1">
+            <a:schemeClr val="accent1"/>
+          </a:lnRef>
+          <a:fillRef idx="3">
+            <a:schemeClr val="accent1"/>
+          </a:fillRef>
+          <a:effectRef idx="2">
+            <a:schemeClr val="accent1"/>
+          </a:effectRef>
+          <a:fontRef idx="minor">
+            <a:schemeClr val="lt1"/>
+          </a:fontRef>
+        </p:style>
+        <p:txBody>
+          <a:bodyPr rtlCol="0" anchor="ctr"/>
+          <a:lstStyle/>
+          <a:p>
+            <a:pPr algn="ctr"/>
+          </a:p>
+        </p:txBody>
+      </p:sp>
+      <p:sp>
+        <p:nvSpPr>
+          <p:cNvPr id="7" name="TextBox 6"/>
+          <p:cNvSpPr txBox="1"/>
+          <p:nvPr/>
+        </p:nvSpPr>
+        <p:spPr>
+          <a:xfrm>
+            <a:off x="813816" y="502920"/>
+            <a:ext cx="10634472" cy="685800"/>
+          </a:xfrm>
+          <a:prstGeom prst="rect">
+            <a:avLst/>
+          </a:prstGeom>
+          <a:noFill/>
+        </p:spPr>
+        <p:txBody>
+          <a:bodyPr wrap="square">
+            <a:spAutoFit/>
+          </a:bodyPr>
+          <a:lstStyle/>
+          <a:p>
+            <a:pPr algn="l"/>
+            <a:r>
+              <a:rPr sz="2400" b="1" i="0">
+                <a:solidFill>
+                  <a:srgbClr val="1F2C56"/>
+                </a:solidFill>
+                <a:latin typeface="Arial"/>
+              </a:rPr>
+              <a:t>Praxisfall: Neuanlage Tischler-Meistermarkt</a:t>
+            </a:r>
+          </a:p>
+        </p:txBody>
+      </p:sp>
+      <p:sp>
+        <p:nvSpPr>
+          <p:cNvPr id="8" name="TextBox 7"/>
+          <p:cNvSpPr txBox="1"/>
+          <p:nvPr/>
+        </p:nvSpPr>
+        <p:spPr>
+          <a:xfrm>
+            <a:off x="685800" y="1417320"/>
+            <a:ext cx="10817352" cy="4892040"/>
+          </a:xfrm>
+          <a:prstGeom prst="rect">
+            <a:avLst/>
+          </a:prstGeom>
+          <a:noFill/>
+        </p:spPr>
+        <p:txBody>
+          <a:bodyPr wrap="square" anchor="ctr">
+            <a:spAutoFit/>
+          </a:bodyPr>
+          <a:lstStyle/>
+          <a:p>
+            <a:pPr>
+              <a:spcBef>
+                <a:spcPts val="1000"/>
+              </a:spcBef>
+              <a:spcAft>
+                <a:spcPts val="200"/>
+              </a:spcAft>
+            </a:pPr>
+            <a:r>
+              <a:rPr sz="800" b="1">
+                <a:solidFill>
+                  <a:srgbClr val="78808C"/>
+                </a:solidFill>
+                <a:latin typeface="Consolas"/>
+              </a:rPr>
+              <a:t>DER FALL</a:t>
+            </a:r>
+          </a:p>
+          <a:p>
+            <a:pPr marL="190500" indent="-190500">
+              <a:spcBef>
+                <a:spcPts val="400"/>
+              </a:spcBef>
+              <a:spcAft>
+                <a:spcPts val="200"/>
+              </a:spcAft>
+            </a:pPr>
+            <a:r>
+              <a:rPr sz="1300">
+                <a:solidFill>
+                  <a:srgbClr val="3D5466"/>
+                </a:solidFill>
+                <a:latin typeface="Arial"/>
+              </a:rPr>
+              <a:t>▸  Die Tischler-Meistermarkt Musterregion GmbH &amp; Co. KG soll als Neukunde angelegt werden.</a:t>
+            </a:r>
+          </a:p>
+          <a:p>
+            <a:pPr marL="190500" indent="-190500">
+              <a:spcBef>
+                <a:spcPts val="400"/>
+              </a:spcBef>
+              <a:spcAft>
+                <a:spcPts val="200"/>
+              </a:spcAft>
+            </a:pPr>
+            <a:r>
+              <a:rPr sz="1300">
+                <a:solidFill>
+                  <a:srgbClr val="3D5466"/>
+                </a:solidFill>
+                <a:latin typeface="Arial"/>
+              </a:rPr>
+              <a:t>▸  Sie erhalten eine Unterlagenübersicht und zwei Handelsregisterauszüge (KG und Komplementär-GmbH).</a:t>
+            </a:r>
+          </a:p>
+          <a:p>
+            <a:pPr>
+              <a:spcBef>
+                <a:spcPts val="1000"/>
+              </a:spcBef>
+              <a:spcAft>
+                <a:spcPts val="200"/>
+              </a:spcAft>
+            </a:pPr>
+            <a:r>
+              <a:rPr sz="800" b="1">
+                <a:solidFill>
+                  <a:srgbClr val="78808C"/>
+                </a:solidFill>
+                <a:latin typeface="Consolas"/>
+              </a:rPr>
+              <a:t>IHRE AUFGABE</a:t>
+            </a:r>
+          </a:p>
+          <a:p>
+            <a:pPr marL="190500" indent="-190500">
+              <a:spcBef>
+                <a:spcPts val="400"/>
+              </a:spcBef>
+              <a:spcAft>
+                <a:spcPts val="200"/>
+              </a:spcAft>
+            </a:pPr>
+            <a:r>
+              <a:rPr sz="1300">
+                <a:solidFill>
+                  <a:srgbClr val="3D5466"/>
+                </a:solidFill>
+                <a:latin typeface="Arial"/>
+              </a:rPr>
+              <a:t>▸  Können Sie den Kundendatensatz anlegen – oder gibt es Probleme? Prüfen Sie Legitimation und Vertretung.</a:t>
+            </a:r>
+          </a:p>
+        </p:txBody>
+      </p:sp>
+      <p:sp>
+        <p:nvSpPr>
+          <p:cNvPr id="9" name="Rectangle 8"/>
+          <p:cNvSpPr/>
+          <p:nvPr/>
+        </p:nvSpPr>
+        <p:spPr>
+          <a:xfrm>
+            <a:off x="0" y="6510528"/>
+            <a:ext cx="12188952" cy="347472"/>
+          </a:xfrm>
+          <a:prstGeom prst="rect">
+            <a:avLst/>
+          </a:prstGeom>
+          <a:solidFill>
+            <a:srgbClr val="0A1937"/>
+          </a:solidFill>
+          <a:ln>
+            <a:noFill/>
+          </a:ln>
+        </p:spPr>
+        <p:style>
+          <a:lnRef idx="1">
+            <a:schemeClr val="accent1"/>
+          </a:lnRef>
+          <a:fillRef idx="3">
+            <a:schemeClr val="accent1"/>
+          </a:fillRef>
+          <a:effectRef idx="2">
+            <a:schemeClr val="accent1"/>
+          </a:effectRef>
+          <a:fontRef idx="minor">
+            <a:schemeClr val="lt1"/>
+          </a:fontRef>
+        </p:style>
+        <p:txBody>
+          <a:bodyPr rtlCol="0" anchor="ctr"/>
+          <a:lstStyle/>
+          <a:p>
+            <a:pPr algn="ctr"/>
+          </a:p>
+        </p:txBody>
+      </p:sp>
+      <p:sp>
+        <p:nvSpPr>
+          <p:cNvPr id="10" name="TextBox 9"/>
+          <p:cNvSpPr txBox="1"/>
+          <p:nvPr/>
+        </p:nvSpPr>
+        <p:spPr>
+          <a:xfrm>
+            <a:off x="685800" y="6583680"/>
+            <a:ext cx="6490411" cy="256032"/>
+          </a:xfrm>
+          <a:prstGeom prst="rect">
+            <a:avLst/>
+          </a:prstGeom>
+          <a:noFill/>
+        </p:spPr>
+        <p:txBody>
+          <a:bodyPr wrap="none">
+            <a:spAutoFit/>
+          </a:bodyPr>
+          <a:lstStyle/>
+          <a:p>
+            <a:pPr algn="l"/>
+            <a:r>
+              <a:rPr sz="700">
+                <a:solidFill>
+                  <a:srgbClr val="A0B4D2"/>
+                </a:solidFill>
+                <a:latin typeface="Consolas"/>
+              </a:rPr>
+              <a:t>FKB Campus  ·  VA10</a:t>
+            </a:r>
+          </a:p>
+        </p:txBody>
+      </p:sp>
+    </p:spTree>
+  </p:cSld>
+  <p:clrMapOvr>
+    <a:masterClrMapping/>
+  </p:clrMapOvr>
+</p:sld>
+</file>
+
+<file path=ppt/slides/slide13.xml><?xml version="1.0" encoding="utf-8"?>
+<p:sld xmlns:a="http://schemas.openxmlformats.org/drawingml/2006/main" xmlns:p="http://schemas.openxmlformats.org/presentationml/2006/main" xmlns:r="http://schemas.openxmlformats.org/officeDocument/2006/relationships">
+  <p:cSld>
+    <p:spTree>
+      <p:nvGrpSpPr>
+        <p:cNvPr id="1" name=""/>
+        <p:cNvGrpSpPr/>
+        <p:nvPr/>
+      </p:nvGrpSpPr>
+      <p:grpSpPr/>
+      <p:sp>
+        <p:nvSpPr>
+          <p:cNvPr id="2" name="Rectangle 1"/>
+          <p:cNvSpPr/>
+          <p:nvPr/>
+        </p:nvSpPr>
+        <p:spPr>
+          <a:xfrm>
+            <a:off x="0" y="0"/>
+            <a:ext cx="12188952" cy="6858000"/>
+          </a:xfrm>
+          <a:prstGeom prst="rect">
+            <a:avLst/>
+          </a:prstGeom>
+          <a:solidFill>
+            <a:srgbClr val="EDEDF3"/>
+          </a:solidFill>
+          <a:ln>
+            <a:noFill/>
+          </a:ln>
+        </p:spPr>
+        <p:style>
+          <a:lnRef idx="1">
+            <a:schemeClr val="accent1"/>
+          </a:lnRef>
+          <a:fillRef idx="3">
+            <a:schemeClr val="accent1"/>
+          </a:fillRef>
+          <a:effectRef idx="2">
+            <a:schemeClr val="accent1"/>
+          </a:effectRef>
+          <a:fontRef idx="minor">
+            <a:schemeClr val="lt1"/>
+          </a:fontRef>
+        </p:style>
+        <p:txBody>
+          <a:bodyPr rtlCol="0" anchor="ctr"/>
+          <a:lstStyle/>
+          <a:p>
+            <a:pPr algn="ctr"/>
+          </a:p>
+        </p:txBody>
+      </p:sp>
+      <p:sp>
+        <p:nvSpPr>
+          <p:cNvPr id="3" name="Rectangle 2"/>
+          <p:cNvSpPr/>
+          <p:nvPr/>
+        </p:nvSpPr>
+        <p:spPr>
+          <a:xfrm>
+            <a:off x="0" y="0"/>
+            <a:ext cx="12188952" cy="50292"/>
+          </a:xfrm>
+          <a:prstGeom prst="rect">
+            <a:avLst/>
+          </a:prstGeom>
+          <a:solidFill>
+            <a:srgbClr val="1F2C56"/>
+          </a:solidFill>
+          <a:ln>
+            <a:noFill/>
+          </a:ln>
+        </p:spPr>
+        <p:style>
+          <a:lnRef idx="1">
+            <a:schemeClr val="accent1"/>
+          </a:lnRef>
+          <a:fillRef idx="3">
+            <a:schemeClr val="accent1"/>
+          </a:fillRef>
+          <a:effectRef idx="2">
+            <a:schemeClr val="accent1"/>
+          </a:effectRef>
+          <a:fontRef idx="minor">
+            <a:schemeClr val="lt1"/>
+          </a:fontRef>
+        </p:style>
+        <p:txBody>
+          <a:bodyPr rtlCol="0" anchor="ctr"/>
+          <a:lstStyle/>
+          <a:p>
+            <a:pPr algn="ctr"/>
+          </a:p>
+        </p:txBody>
+      </p:sp>
+      <p:sp>
+        <p:nvSpPr>
+          <p:cNvPr id="4" name="TextBox 3"/>
+          <p:cNvSpPr txBox="1"/>
+          <p:nvPr/>
+        </p:nvSpPr>
+        <p:spPr>
+          <a:xfrm>
+            <a:off x="685800" y="109728"/>
+            <a:ext cx="10817352" cy="228600"/>
+          </a:xfrm>
+          <a:prstGeom prst="rect">
+            <a:avLst/>
+          </a:prstGeom>
+          <a:noFill/>
+        </p:spPr>
+        <p:txBody>
+          <a:bodyPr wrap="none">
+            <a:spAutoFit/>
+          </a:bodyPr>
+          <a:lstStyle/>
+          <a:p>
+            <a:pPr algn="l"/>
+            <a:r>
+              <a:rPr sz="750">
+                <a:solidFill>
+                  <a:srgbClr val="78808C"/>
+                </a:solidFill>
+                <a:latin typeface="Consolas"/>
+              </a:rPr>
+              <a:t>VA10  ·  INHALT</a:t>
+            </a:r>
+          </a:p>
+        </p:txBody>
+      </p:sp>
+      <p:sp>
+        <p:nvSpPr>
+          <p:cNvPr id="5" name="Rectangle 4"/>
+          <p:cNvSpPr/>
+          <p:nvPr/>
+        </p:nvSpPr>
+        <p:spPr>
+          <a:xfrm>
+            <a:off x="0" y="1234440"/>
+            <a:ext cx="12188952" cy="12700"/>
+          </a:xfrm>
+          <a:prstGeom prst="rect">
+            <a:avLst/>
+          </a:prstGeom>
+          <a:solidFill>
+            <a:srgbClr val="D8DFE4"/>
+          </a:solidFill>
+          <a:ln>
+            <a:noFill/>
+          </a:ln>
+        </p:spPr>
+        <p:style>
+          <a:lnRef idx="1">
+            <a:schemeClr val="accent1"/>
+          </a:lnRef>
+          <a:fillRef idx="3">
+            <a:schemeClr val="accent1"/>
+          </a:fillRef>
+          <a:effectRef idx="2">
+            <a:schemeClr val="accent1"/>
+          </a:effectRef>
+          <a:fontRef idx="minor">
+            <a:schemeClr val="lt1"/>
+          </a:fontRef>
+        </p:style>
+        <p:txBody>
+          <a:bodyPr rtlCol="0" anchor="ctr"/>
+          <a:lstStyle/>
+          <a:p>
+            <a:pPr algn="ctr"/>
+          </a:p>
+        </p:txBody>
+      </p:sp>
+      <p:sp>
+        <p:nvSpPr>
+          <p:cNvPr id="6" name="Rectangle 5"/>
+          <p:cNvSpPr/>
+          <p:nvPr/>
+        </p:nvSpPr>
+        <p:spPr>
+          <a:xfrm>
+            <a:off x="685800" y="502920"/>
+            <a:ext cx="36576" cy="658368"/>
+          </a:xfrm>
+          <a:prstGeom prst="rect">
+            <a:avLst/>
+          </a:prstGeom>
+          <a:solidFill>
+            <a:srgbClr val="D9C089"/>
+          </a:solidFill>
+          <a:ln>
+            <a:noFill/>
+          </a:ln>
+        </p:spPr>
+        <p:style>
+          <a:lnRef idx="1">
+            <a:schemeClr val="accent1"/>
+          </a:lnRef>
+          <a:fillRef idx="3">
+            <a:schemeClr val="accent1"/>
+          </a:fillRef>
+          <a:effectRef idx="2">
+            <a:schemeClr val="accent1"/>
+          </a:effectRef>
+          <a:fontRef idx="minor">
+            <a:schemeClr val="lt1"/>
+          </a:fontRef>
+        </p:style>
+        <p:txBody>
+          <a:bodyPr rtlCol="0" anchor="ctr"/>
+          <a:lstStyle/>
+          <a:p>
+            <a:pPr algn="ctr"/>
+          </a:p>
+        </p:txBody>
+      </p:sp>
+      <p:sp>
+        <p:nvSpPr>
+          <p:cNvPr id="7" name="TextBox 6"/>
+          <p:cNvSpPr txBox="1"/>
+          <p:nvPr/>
+        </p:nvSpPr>
+        <p:spPr>
+          <a:xfrm>
+            <a:off x="813816" y="502920"/>
+            <a:ext cx="10634472" cy="685800"/>
+          </a:xfrm>
+          <a:prstGeom prst="rect">
+            <a:avLst/>
+          </a:prstGeom>
+          <a:noFill/>
+        </p:spPr>
+        <p:txBody>
+          <a:bodyPr wrap="square">
+            <a:spAutoFit/>
+          </a:bodyPr>
+          <a:lstStyle/>
+          <a:p>
+            <a:pPr algn="l"/>
+            <a:r>
+              <a:rPr sz="2400" b="1" i="0">
+                <a:solidFill>
+                  <a:srgbClr val="1F2C56"/>
+                </a:solidFill>
+                <a:latin typeface="Arial"/>
+              </a:rPr>
+              <a:t>Handlungsempfehlung: prüfen, stoppen, eskalieren</a:t>
+            </a:r>
+          </a:p>
+        </p:txBody>
+      </p:sp>
+      <p:sp>
+        <p:nvSpPr>
+          <p:cNvPr id="8" name="TextBox 7"/>
+          <p:cNvSpPr txBox="1"/>
+          <p:nvPr/>
+        </p:nvSpPr>
+        <p:spPr>
+          <a:xfrm>
+            <a:off x="685800" y="1417320"/>
+            <a:ext cx="10817352" cy="4892040"/>
+          </a:xfrm>
+          <a:prstGeom prst="rect">
+            <a:avLst/>
+          </a:prstGeom>
+          <a:noFill/>
+        </p:spPr>
+        <p:txBody>
+          <a:bodyPr wrap="square" anchor="ctr">
+            <a:spAutoFit/>
+          </a:bodyPr>
+          <a:lstStyle/>
+          <a:p>
+            <a:pPr marL="177800" indent="-177800">
+              <a:spcBef>
+                <a:spcPts val="600"/>
+              </a:spcBef>
+              <a:spcAft>
+                <a:spcPts val="200"/>
+              </a:spcAft>
+            </a:pPr>
+            <a:r>
+              <a:rPr sz="1200" i="1">
+                <a:solidFill>
+                  <a:srgbClr val="3D5466"/>
+                </a:solidFill>
+                <a:latin typeface="Arial"/>
+              </a:rPr>
+              <a:t>→  Wenn kein aktueller Registerauszug vorliegt — dann Anlage im System stoppen und den Berater informieren; kein Konto ohne vollständige Legitimation.</a:t>
+            </a:r>
+          </a:p>
+          <a:p>
+            <a:pPr marL="177800" indent="-177800">
+              <a:spcBef>
+                <a:spcPts val="600"/>
+              </a:spcBef>
+              <a:spcAft>
+                <a:spcPts val="200"/>
+              </a:spcAft>
+            </a:pPr>
+            <a:r>
+              <a:rPr sz="1200" i="1">
+                <a:solidFill>
+                  <a:srgbClr val="3D5466"/>
+                </a:solidFill>
+                <a:latin typeface="Arial"/>
+              </a:rPr>
+              <a:t>→  Wenn der HR-Auszug Gesamtvertretung ausweist, aber nur eine Unterschrift vorliegt — dann als unvollständig kennzeichnen und Nachzeichnung veranlassen.</a:t>
+            </a:r>
+          </a:p>
+          <a:p>
+            <a:pPr marL="177800" indent="-177800">
+              <a:spcBef>
+                <a:spcPts val="600"/>
+              </a:spcBef>
+              <a:spcAft>
+                <a:spcPts val="200"/>
+              </a:spcAft>
+            </a:pPr>
+            <a:r>
+              <a:rPr sz="1200" i="1">
+                <a:solidFill>
+                  <a:srgbClr val="3D5466"/>
+                </a:solidFill>
+                <a:latin typeface="Arial"/>
+              </a:rPr>
+              <a:t>→  Wenn der Handelsregisterauszug älter als drei Monate ist — dann einen aktuellen Auszug abrufen; Vertretungsverhältnisse können sich geändert haben.</a:t>
+            </a:r>
+          </a:p>
+        </p:txBody>
+      </p:sp>
+      <p:sp>
+        <p:nvSpPr>
+          <p:cNvPr id="9" name="Rectangle 8"/>
+          <p:cNvSpPr/>
+          <p:nvPr/>
+        </p:nvSpPr>
+        <p:spPr>
+          <a:xfrm>
+            <a:off x="0" y="6510528"/>
+            <a:ext cx="12188952" cy="347472"/>
+          </a:xfrm>
+          <a:prstGeom prst="rect">
+            <a:avLst/>
+          </a:prstGeom>
+          <a:solidFill>
+            <a:srgbClr val="0A1937"/>
+          </a:solidFill>
+          <a:ln>
+            <a:noFill/>
+          </a:ln>
+        </p:spPr>
+        <p:style>
+          <a:lnRef idx="1">
+            <a:schemeClr val="accent1"/>
+          </a:lnRef>
+          <a:fillRef idx="3">
+            <a:schemeClr val="accent1"/>
+          </a:fillRef>
+          <a:effectRef idx="2">
+            <a:schemeClr val="accent1"/>
+          </a:effectRef>
+          <a:fontRef idx="minor">
+            <a:schemeClr val="lt1"/>
+          </a:fontRef>
+        </p:style>
+        <p:txBody>
+          <a:bodyPr rtlCol="0" anchor="ctr"/>
+          <a:lstStyle/>
+          <a:p>
+            <a:pPr algn="ctr"/>
+          </a:p>
+        </p:txBody>
+      </p:sp>
+      <p:sp>
+        <p:nvSpPr>
+          <p:cNvPr id="10" name="TextBox 9"/>
+          <p:cNvSpPr txBox="1"/>
+          <p:nvPr/>
+        </p:nvSpPr>
+        <p:spPr>
+          <a:xfrm>
+            <a:off x="685800" y="6583680"/>
+            <a:ext cx="6490411" cy="256032"/>
+          </a:xfrm>
+          <a:prstGeom prst="rect">
+            <a:avLst/>
+          </a:prstGeom>
+          <a:noFill/>
+        </p:spPr>
+        <p:txBody>
+          <a:bodyPr wrap="none">
+            <a:spAutoFit/>
+          </a:bodyPr>
+          <a:lstStyle/>
+          <a:p>
+            <a:pPr algn="l"/>
+            <a:r>
+              <a:rPr sz="700">
+                <a:solidFill>
+                  <a:srgbClr val="A0B4D2"/>
+                </a:solidFill>
+                <a:latin typeface="Consolas"/>
+              </a:rPr>
+              <a:t>FKB Campus  ·  VA10</a:t>
+            </a:r>
+          </a:p>
+        </p:txBody>
+      </p:sp>
+    </p:spTree>
+  </p:cSld>
+  <p:clrMapOvr>
+    <a:masterClrMapping/>
+  </p:clrMapOvr>
+</p:sld>
+</file>
+
+<file path=ppt/slides/slide14.xml><?xml version="1.0" encoding="utf-8"?>
+<p:sld xmlns:a="http://schemas.openxmlformats.org/drawingml/2006/main" xmlns:p="http://schemas.openxmlformats.org/presentationml/2006/main" xmlns:r="http://schemas.openxmlformats.org/officeDocument/2006/relationships">
+  <p:cSld>
+    <p:spTree>
+      <p:nvGrpSpPr>
+        <p:cNvPr id="1" name=""/>
+        <p:cNvGrpSpPr/>
+        <p:nvPr/>
+      </p:nvGrpSpPr>
+      <p:grpSpPr/>
+      <p:sp>
+        <p:nvSpPr>
+          <p:cNvPr id="2" name="Rectangle 1"/>
+          <p:cNvSpPr/>
+          <p:nvPr/>
+        </p:nvSpPr>
+        <p:spPr>
+          <a:xfrm>
+            <a:off x="0" y="0"/>
+            <a:ext cx="12188952" cy="6858000"/>
+          </a:xfrm>
+          <a:prstGeom prst="rect">
+            <a:avLst/>
+          </a:prstGeom>
+          <a:solidFill>
+            <a:srgbClr val="EDEDF3"/>
+          </a:solidFill>
+          <a:ln>
+            <a:noFill/>
+          </a:ln>
+        </p:spPr>
+        <p:style>
+          <a:lnRef idx="1">
+            <a:schemeClr val="accent1"/>
+          </a:lnRef>
+          <a:fillRef idx="3">
+            <a:schemeClr val="accent1"/>
+          </a:fillRef>
+          <a:effectRef idx="2">
+            <a:schemeClr val="accent1"/>
+          </a:effectRef>
+          <a:fontRef idx="minor">
+            <a:schemeClr val="lt1"/>
+          </a:fontRef>
+        </p:style>
+        <p:txBody>
+          <a:bodyPr rtlCol="0" anchor="ctr"/>
+          <a:lstStyle/>
+          <a:p>
+            <a:pPr algn="ctr"/>
+          </a:p>
+        </p:txBody>
+      </p:sp>
+      <p:sp>
+        <p:nvSpPr>
+          <p:cNvPr id="3" name="Rectangle 2"/>
+          <p:cNvSpPr/>
+          <p:nvPr/>
+        </p:nvSpPr>
+        <p:spPr>
+          <a:xfrm>
+            <a:off x="0" y="0"/>
+            <a:ext cx="12188952" cy="50292"/>
+          </a:xfrm>
+          <a:prstGeom prst="rect">
+            <a:avLst/>
+          </a:prstGeom>
+          <a:solidFill>
+            <a:srgbClr val="1F2C56"/>
+          </a:solidFill>
+          <a:ln>
+            <a:noFill/>
+          </a:ln>
+        </p:spPr>
+        <p:style>
+          <a:lnRef idx="1">
+            <a:schemeClr val="accent1"/>
+          </a:lnRef>
+          <a:fillRef idx="3">
+            <a:schemeClr val="accent1"/>
+          </a:fillRef>
+          <a:effectRef idx="2">
+            <a:schemeClr val="accent1"/>
+          </a:effectRef>
+          <a:fontRef idx="minor">
+            <a:schemeClr val="lt1"/>
+          </a:fontRef>
+        </p:style>
+        <p:txBody>
+          <a:bodyPr rtlCol="0" anchor="ctr"/>
+          <a:lstStyle/>
+          <a:p>
+            <a:pPr algn="ctr"/>
+          </a:p>
+        </p:txBody>
+      </p:sp>
+      <p:sp>
+        <p:nvSpPr>
+          <p:cNvPr id="4" name="TextBox 3"/>
+          <p:cNvSpPr txBox="1"/>
+          <p:nvPr/>
+        </p:nvSpPr>
+        <p:spPr>
+          <a:xfrm>
+            <a:off x="685800" y="109728"/>
+            <a:ext cx="10817352" cy="228600"/>
+          </a:xfrm>
+          <a:prstGeom prst="rect">
+            <a:avLst/>
+          </a:prstGeom>
+          <a:noFill/>
+        </p:spPr>
+        <p:txBody>
+          <a:bodyPr wrap="none">
+            <a:spAutoFit/>
+          </a:bodyPr>
+          <a:lstStyle/>
+          <a:p>
+            <a:pPr algn="l"/>
+            <a:r>
+              <a:rPr sz="750">
+                <a:solidFill>
+                  <a:srgbClr val="78808C"/>
+                </a:solidFill>
+                <a:latin typeface="Consolas"/>
+              </a:rPr>
+              <a:t>VA10  ·  ARBEITSBLATT</a:t>
+            </a:r>
+          </a:p>
+        </p:txBody>
+      </p:sp>
+      <p:sp>
+        <p:nvSpPr>
+          <p:cNvPr id="5" name="Rectangle 4"/>
+          <p:cNvSpPr/>
+          <p:nvPr/>
+        </p:nvSpPr>
+        <p:spPr>
+          <a:xfrm>
+            <a:off x="0" y="1234440"/>
+            <a:ext cx="12188952" cy="12700"/>
+          </a:xfrm>
+          <a:prstGeom prst="rect">
+            <a:avLst/>
+          </a:prstGeom>
+          <a:solidFill>
+            <a:srgbClr val="D8DFE4"/>
+          </a:solidFill>
+          <a:ln>
+            <a:noFill/>
+          </a:ln>
+        </p:spPr>
+        <p:style>
+          <a:lnRef idx="1">
+            <a:schemeClr val="accent1"/>
+          </a:lnRef>
+          <a:fillRef idx="3">
+            <a:schemeClr val="accent1"/>
+          </a:fillRef>
+          <a:effectRef idx="2">
+            <a:schemeClr val="accent1"/>
+          </a:effectRef>
+          <a:fontRef idx="minor">
+            <a:schemeClr val="lt1"/>
+          </a:fontRef>
+        </p:style>
+        <p:txBody>
+          <a:bodyPr rtlCol="0" anchor="ctr"/>
+          <a:lstStyle/>
+          <a:p>
+            <a:pPr algn="ctr"/>
+          </a:p>
+        </p:txBody>
+      </p:sp>
+      <p:sp>
+        <p:nvSpPr>
+          <p:cNvPr id="6" name="Rectangle 5"/>
+          <p:cNvSpPr/>
+          <p:nvPr/>
+        </p:nvSpPr>
+        <p:spPr>
+          <a:xfrm>
+            <a:off x="685800" y="502920"/>
+            <a:ext cx="36576" cy="658368"/>
+          </a:xfrm>
+          <a:prstGeom prst="rect">
+            <a:avLst/>
+          </a:prstGeom>
+          <a:solidFill>
+            <a:srgbClr val="D9C089"/>
+          </a:solidFill>
+          <a:ln>
+            <a:noFill/>
+          </a:ln>
+        </p:spPr>
+        <p:style>
+          <a:lnRef idx="1">
+            <a:schemeClr val="accent1"/>
+          </a:lnRef>
+          <a:fillRef idx="3">
+            <a:schemeClr val="accent1"/>
+          </a:fillRef>
+          <a:effectRef idx="2">
+            <a:schemeClr val="accent1"/>
+          </a:effectRef>
+          <a:fontRef idx="minor">
+            <a:schemeClr val="lt1"/>
+          </a:fontRef>
+        </p:style>
+        <p:txBody>
+          <a:bodyPr rtlCol="0" anchor="ctr"/>
+          <a:lstStyle/>
+          <a:p>
+            <a:pPr algn="ctr"/>
+          </a:p>
+        </p:txBody>
+      </p:sp>
+      <p:sp>
+        <p:nvSpPr>
+          <p:cNvPr id="7" name="TextBox 6"/>
+          <p:cNvSpPr txBox="1"/>
+          <p:nvPr/>
+        </p:nvSpPr>
+        <p:spPr>
+          <a:xfrm>
+            <a:off x="813816" y="502920"/>
+            <a:ext cx="10634472" cy="685800"/>
+          </a:xfrm>
+          <a:prstGeom prst="rect">
+            <a:avLst/>
+          </a:prstGeom>
+          <a:noFill/>
+        </p:spPr>
+        <p:txBody>
+          <a:bodyPr wrap="square">
+            <a:spAutoFit/>
+          </a:bodyPr>
+          <a:lstStyle/>
+          <a:p>
+            <a:pPr algn="l"/>
+            <a:r>
+              <a:rPr sz="2400" b="1" i="0">
+                <a:solidFill>
+                  <a:srgbClr val="1F2C56"/>
+                </a:solidFill>
+                <a:latin typeface="Arial"/>
+              </a:rPr>
+              <a:t>Praxisfall bearbeiten: Anlage prüfen</a:t>
+            </a:r>
+          </a:p>
+        </p:txBody>
+      </p:sp>
+      <p:sp>
+        <p:nvSpPr>
+          <p:cNvPr id="8" name="TextBox 7"/>
+          <p:cNvSpPr txBox="1"/>
+          <p:nvPr/>
+        </p:nvSpPr>
+        <p:spPr>
+          <a:xfrm>
+            <a:off x="685800" y="1554480"/>
+            <a:ext cx="10817352" cy="3840480"/>
+          </a:xfrm>
+          <a:prstGeom prst="rect">
+            <a:avLst/>
+          </a:prstGeom>
+          <a:noFill/>
+        </p:spPr>
+        <p:txBody>
+          <a:bodyPr wrap="square">
+            <a:spAutoFit/>
+          </a:bodyPr>
+          <a:lstStyle/>
+          <a:p>
+            <a:pPr marL="190500" indent="-190500">
+              <a:spcBef>
+                <a:spcPts val="400"/>
+              </a:spcBef>
+              <a:spcAft>
+                <a:spcPts val="200"/>
+              </a:spcAft>
+            </a:pPr>
+            <a:r>
+              <a:rPr sz="1400">
+                <a:solidFill>
+                  <a:srgbClr val="3D5466"/>
+                </a:solidFill>
+                <a:latin typeface="Arial"/>
+              </a:rPr>
+              <a:t>▸  Ordnen Sie die Legitimationsunterlagen je Rechtsform zu (AB-1).</a:t>
+            </a:r>
+          </a:p>
+          <a:p>
+            <a:pPr marL="190500" indent="-190500">
+              <a:spcBef>
+                <a:spcPts val="400"/>
+              </a:spcBef>
+              <a:spcAft>
+                <a:spcPts val="200"/>
+              </a:spcAft>
+            </a:pPr>
+            <a:r>
+              <a:rPr sz="1400">
+                <a:solidFill>
+                  <a:srgbClr val="3D5466"/>
+                </a:solidFill>
+                <a:latin typeface="Arial"/>
+              </a:rPr>
+              <a:t>▸  Lesen Sie den HR-Auszug und bestimmen Sie die Vertretungsregelung (AB-2).</a:t>
+            </a:r>
+          </a:p>
+          <a:p>
+            <a:pPr marL="190500" indent="-190500">
+              <a:spcBef>
+                <a:spcPts val="400"/>
+              </a:spcBef>
+              <a:spcAft>
+                <a:spcPts val="200"/>
+              </a:spcAft>
+            </a:pPr>
+            <a:r>
+              <a:rPr sz="1400">
+                <a:solidFill>
+                  <a:srgbClr val="3D5466"/>
+                </a:solidFill>
+                <a:latin typeface="Arial"/>
+              </a:rPr>
+              <a:t>▸  Prüfen Sie Vollmacht und Zeichnungsberechtigung im Frau-Hofmann-Fall (AB-3).</a:t>
+            </a:r>
+          </a:p>
+          <a:p>
+            <a:pPr marL="190500" indent="-190500">
+              <a:spcBef>
+                <a:spcPts val="400"/>
+              </a:spcBef>
+              <a:spcAft>
+                <a:spcPts val="200"/>
+              </a:spcAft>
+            </a:pPr>
+            <a:r>
+              <a:rPr sz="1400">
+                <a:solidFill>
+                  <a:srgbClr val="3D5466"/>
+                </a:solidFill>
+                <a:latin typeface="Arial"/>
+              </a:rPr>
+              <a:t>▸  Erkennen Sie die Formfehler in den Beispielunterlagen (AB-4) – Prüfkarte AB-5 als Werkzeug.</a:t>
+            </a:r>
+          </a:p>
+        </p:txBody>
+      </p:sp>
+      <p:sp>
+        <p:nvSpPr>
+          <p:cNvPr id="9" name="Rectangle 8"/>
+          <p:cNvSpPr/>
+          <p:nvPr/>
+        </p:nvSpPr>
+        <p:spPr>
+          <a:xfrm>
+            <a:off x="685800" y="5486400"/>
+            <a:ext cx="10817352" cy="640080"/>
+          </a:xfrm>
+          <a:prstGeom prst="rect">
+            <a:avLst/>
+          </a:prstGeom>
+          <a:solidFill>
+            <a:srgbClr val="1F2C56"/>
+          </a:solidFill>
+          <a:ln>
+            <a:noFill/>
+          </a:ln>
+        </p:spPr>
+        <p:style>
+          <a:lnRef idx="1">
+            <a:schemeClr val="accent1"/>
+          </a:lnRef>
+          <a:fillRef idx="3">
+            <a:schemeClr val="accent1"/>
+          </a:fillRef>
+          <a:effectRef idx="2">
+            <a:schemeClr val="accent1"/>
+          </a:effectRef>
+          <a:fontRef idx="minor">
+            <a:schemeClr val="lt1"/>
+          </a:fontRef>
+        </p:style>
+        <p:txBody>
+          <a:bodyPr rtlCol="0" anchor="ctr"/>
+          <a:lstStyle/>
+          <a:p>
+            <a:pPr algn="ctr"/>
+          </a:p>
+        </p:txBody>
+      </p:sp>
+      <p:sp>
+        <p:nvSpPr>
+          <p:cNvPr id="10" name="TextBox 9"/>
+          <p:cNvSpPr txBox="1"/>
+          <p:nvPr/>
+        </p:nvSpPr>
+        <p:spPr>
+          <a:xfrm>
+            <a:off x="868680" y="5596128"/>
+            <a:ext cx="10451592" cy="457200"/>
+          </a:xfrm>
+          <a:prstGeom prst="rect">
+            <a:avLst/>
+          </a:prstGeom>
+          <a:noFill/>
+        </p:spPr>
+        <p:txBody>
+          <a:bodyPr wrap="square">
+            <a:spAutoFit/>
+          </a:bodyPr>
+          <a:lstStyle/>
+          <a:p>
+            <a:pPr algn="l"/>
+            <a:r>
+              <a:rPr sz="1300" b="1" i="0">
+                <a:solidFill>
+                  <a:srgbClr val="FFFFFF"/>
+                </a:solidFill>
+                <a:latin typeface="Arial"/>
+              </a:rPr>
+              <a:t>→  Bearbeitung im Teilnehmer-Workbook (Arbeitsblatt mit Ausfüllfeldern)</a:t>
+            </a:r>
+          </a:p>
+        </p:txBody>
+      </p:sp>
+      <p:sp>
+        <p:nvSpPr>
+          <p:cNvPr id="11" name="Rectangle 10"/>
+          <p:cNvSpPr/>
+          <p:nvPr/>
+        </p:nvSpPr>
+        <p:spPr>
+          <a:xfrm>
+            <a:off x="0" y="6510528"/>
+            <a:ext cx="12188952" cy="347472"/>
+          </a:xfrm>
+          <a:prstGeom prst="rect">
+            <a:avLst/>
+          </a:prstGeom>
+          <a:solidFill>
+            <a:srgbClr val="0A1937"/>
+          </a:solidFill>
+          <a:ln>
+            <a:noFill/>
+          </a:ln>
+        </p:spPr>
+        <p:style>
+          <a:lnRef idx="1">
+            <a:schemeClr val="accent1"/>
+          </a:lnRef>
+          <a:fillRef idx="3">
+            <a:schemeClr val="accent1"/>
+          </a:fillRef>
+          <a:effectRef idx="2">
+            <a:schemeClr val="accent1"/>
+          </a:effectRef>
+          <a:fontRef idx="minor">
+            <a:schemeClr val="lt1"/>
+          </a:fontRef>
+        </p:style>
+        <p:txBody>
+          <a:bodyPr rtlCol="0" anchor="ctr"/>
+          <a:lstStyle/>
+          <a:p>
+            <a:pPr algn="ctr"/>
+          </a:p>
+        </p:txBody>
+      </p:sp>
+      <p:sp>
+        <p:nvSpPr>
+          <p:cNvPr id="12" name="TextBox 11"/>
+          <p:cNvSpPr txBox="1"/>
+          <p:nvPr/>
+        </p:nvSpPr>
+        <p:spPr>
+          <a:xfrm>
+            <a:off x="685800" y="6583680"/>
+            <a:ext cx="6490411" cy="256032"/>
+          </a:xfrm>
+          <a:prstGeom prst="rect">
+            <a:avLst/>
+          </a:prstGeom>
+          <a:noFill/>
+        </p:spPr>
+        <p:txBody>
+          <a:bodyPr wrap="none">
+            <a:spAutoFit/>
+          </a:bodyPr>
+          <a:lstStyle/>
+          <a:p>
+            <a:pPr algn="l"/>
+            <a:r>
+              <a:rPr sz="700">
+                <a:solidFill>
+                  <a:srgbClr val="A0B4D2"/>
+                </a:solidFill>
+                <a:latin typeface="Consolas"/>
+              </a:rPr>
+              <a:t>FKB Campus  ·  VA10</a:t>
+            </a:r>
+          </a:p>
+        </p:txBody>
+      </p:sp>
+    </p:spTree>
+  </p:cSld>
+  <p:clrMapOvr>
+    <a:masterClrMapping/>
+  </p:clrMapOvr>
+</p:sld>
+</file>
+
+<file path=ppt/slides/slide15.xml><?xml version="1.0" encoding="utf-8"?>
+<p:sld xmlns:a="http://schemas.openxmlformats.org/drawingml/2006/main" xmlns:p="http://schemas.openxmlformats.org/presentationml/2006/main" xmlns:r="http://schemas.openxmlformats.org/officeDocument/2006/relationships">
+  <p:cSld>
+    <p:spTree>
+      <p:nvGrpSpPr>
+        <p:cNvPr id="1" name=""/>
+        <p:cNvGrpSpPr/>
+        <p:nvPr/>
+      </p:nvGrpSpPr>
+      <p:grpSpPr/>
+      <p:sp>
+        <p:nvSpPr>
+          <p:cNvPr id="2" name="Rectangle 1"/>
+          <p:cNvSpPr/>
+          <p:nvPr/>
+        </p:nvSpPr>
+        <p:spPr>
+          <a:xfrm>
+            <a:off x="0" y="0"/>
+            <a:ext cx="12188952" cy="6858000"/>
+          </a:xfrm>
+          <a:prstGeom prst="rect">
+            <a:avLst/>
+          </a:prstGeom>
+          <a:solidFill>
+            <a:srgbClr val="EDEDF3"/>
+          </a:solidFill>
+          <a:ln>
+            <a:noFill/>
+          </a:ln>
+        </p:spPr>
+        <p:style>
+          <a:lnRef idx="1">
+            <a:schemeClr val="accent1"/>
+          </a:lnRef>
+          <a:fillRef idx="3">
+            <a:schemeClr val="accent1"/>
+          </a:fillRef>
+          <a:effectRef idx="2">
+            <a:schemeClr val="accent1"/>
+          </a:effectRef>
+          <a:fontRef idx="minor">
+            <a:schemeClr val="lt1"/>
+          </a:fontRef>
+        </p:style>
+        <p:txBody>
+          <a:bodyPr rtlCol="0" anchor="ctr"/>
+          <a:lstStyle/>
+          <a:p>
+            <a:pPr algn="ctr"/>
+          </a:p>
+        </p:txBody>
+      </p:sp>
+      <p:sp>
+        <p:nvSpPr>
+          <p:cNvPr id="3" name="Rectangle 2"/>
+          <p:cNvSpPr/>
+          <p:nvPr/>
+        </p:nvSpPr>
+        <p:spPr>
+          <a:xfrm>
+            <a:off x="0" y="0"/>
+            <a:ext cx="12188952" cy="50292"/>
+          </a:xfrm>
+          <a:prstGeom prst="rect">
+            <a:avLst/>
+          </a:prstGeom>
+          <a:solidFill>
+            <a:srgbClr val="1F2C56"/>
+          </a:solidFill>
+          <a:ln>
+            <a:noFill/>
+          </a:ln>
+        </p:spPr>
+        <p:style>
+          <a:lnRef idx="1">
+            <a:schemeClr val="accent1"/>
+          </a:lnRef>
+          <a:fillRef idx="3">
+            <a:schemeClr val="accent1"/>
+          </a:fillRef>
+          <a:effectRef idx="2">
+            <a:schemeClr val="accent1"/>
+          </a:effectRef>
+          <a:fontRef idx="minor">
+            <a:schemeClr val="lt1"/>
+          </a:fontRef>
+        </p:style>
+        <p:txBody>
+          <a:bodyPr rtlCol="0" anchor="ctr"/>
+          <a:lstStyle/>
+          <a:p>
+            <a:pPr algn="ctr"/>
+          </a:p>
+        </p:txBody>
+      </p:sp>
+      <p:sp>
+        <p:nvSpPr>
+          <p:cNvPr id="4" name="TextBox 3"/>
+          <p:cNvSpPr txBox="1"/>
+          <p:nvPr/>
+        </p:nvSpPr>
+        <p:spPr>
+          <a:xfrm>
+            <a:off x="685800" y="109728"/>
+            <a:ext cx="10817352" cy="228600"/>
+          </a:xfrm>
+          <a:prstGeom prst="rect">
+            <a:avLst/>
+          </a:prstGeom>
+          <a:noFill/>
+        </p:spPr>
+        <p:txBody>
+          <a:bodyPr wrap="none">
+            <a:spAutoFit/>
+          </a:bodyPr>
+          <a:lstStyle/>
+          <a:p>
+            <a:pPr algn="l"/>
+            <a:r>
+              <a:rPr sz="750">
+                <a:solidFill>
+                  <a:srgbClr val="78808C"/>
+                </a:solidFill>
+                <a:latin typeface="Consolas"/>
+              </a:rPr>
+              <a:t>VA10  ·  INHALT</a:t>
+            </a:r>
+          </a:p>
+        </p:txBody>
+      </p:sp>
+      <p:sp>
+        <p:nvSpPr>
+          <p:cNvPr id="5" name="Rectangle 4"/>
+          <p:cNvSpPr/>
+          <p:nvPr/>
+        </p:nvSpPr>
+        <p:spPr>
+          <a:xfrm>
+            <a:off x="0" y="1234440"/>
+            <a:ext cx="12188952" cy="12700"/>
+          </a:xfrm>
+          <a:prstGeom prst="rect">
+            <a:avLst/>
+          </a:prstGeom>
+          <a:solidFill>
+            <a:srgbClr val="D8DFE4"/>
+          </a:solidFill>
+          <a:ln>
+            <a:noFill/>
+          </a:ln>
+        </p:spPr>
+        <p:style>
+          <a:lnRef idx="1">
+            <a:schemeClr val="accent1"/>
+          </a:lnRef>
+          <a:fillRef idx="3">
+            <a:schemeClr val="accent1"/>
+          </a:fillRef>
+          <a:effectRef idx="2">
+            <a:schemeClr val="accent1"/>
+          </a:effectRef>
+          <a:fontRef idx="minor">
+            <a:schemeClr val="lt1"/>
+          </a:fontRef>
+        </p:style>
+        <p:txBody>
+          <a:bodyPr rtlCol="0" anchor="ctr"/>
+          <a:lstStyle/>
+          <a:p>
+            <a:pPr algn="ctr"/>
+          </a:p>
+        </p:txBody>
+      </p:sp>
+      <p:sp>
+        <p:nvSpPr>
+          <p:cNvPr id="6" name="Rectangle 5"/>
+          <p:cNvSpPr/>
+          <p:nvPr/>
+        </p:nvSpPr>
+        <p:spPr>
+          <a:xfrm>
+            <a:off x="685800" y="502920"/>
+            <a:ext cx="36576" cy="658368"/>
+          </a:xfrm>
+          <a:prstGeom prst="rect">
+            <a:avLst/>
+          </a:prstGeom>
+          <a:solidFill>
+            <a:srgbClr val="D9C089"/>
+          </a:solidFill>
+          <a:ln>
+            <a:noFill/>
+          </a:ln>
+        </p:spPr>
+        <p:style>
+          <a:lnRef idx="1">
+            <a:schemeClr val="accent1"/>
+          </a:lnRef>
+          <a:fillRef idx="3">
+            <a:schemeClr val="accent1"/>
+          </a:fillRef>
+          <a:effectRef idx="2">
+            <a:schemeClr val="accent1"/>
+          </a:effectRef>
+          <a:fontRef idx="minor">
+            <a:schemeClr val="lt1"/>
+          </a:fontRef>
+        </p:style>
+        <p:txBody>
+          <a:bodyPr rtlCol="0" anchor="ctr"/>
+          <a:lstStyle/>
+          <a:p>
+            <a:pPr algn="ctr"/>
+          </a:p>
+        </p:txBody>
+      </p:sp>
+      <p:sp>
+        <p:nvSpPr>
+          <p:cNvPr id="7" name="TextBox 6"/>
+          <p:cNvSpPr txBox="1"/>
+          <p:nvPr/>
+        </p:nvSpPr>
+        <p:spPr>
+          <a:xfrm>
+            <a:off x="813816" y="502920"/>
+            <a:ext cx="10634472" cy="685800"/>
+          </a:xfrm>
+          <a:prstGeom prst="rect">
+            <a:avLst/>
+          </a:prstGeom>
+          <a:noFill/>
+        </p:spPr>
+        <p:txBody>
+          <a:bodyPr wrap="square">
+            <a:spAutoFit/>
+          </a:bodyPr>
+          <a:lstStyle/>
+          <a:p>
+            <a:pPr algn="l"/>
+            <a:r>
+              <a:rPr sz="2400" b="1" i="0">
+                <a:solidFill>
+                  <a:srgbClr val="1F2C56"/>
+                </a:solidFill>
+                <a:latin typeface="Arial"/>
+              </a:rPr>
+              <a:t>Prinzip dieses Moduls</a:t>
+            </a:r>
+          </a:p>
+        </p:txBody>
+      </p:sp>
+      <p:sp>
+        <p:nvSpPr>
+          <p:cNvPr id="8" name="TextBox 7"/>
+          <p:cNvSpPr txBox="1"/>
+          <p:nvPr/>
+        </p:nvSpPr>
+        <p:spPr>
+          <a:xfrm>
+            <a:off x="685800" y="1417320"/>
+            <a:ext cx="10817352" cy="4892040"/>
+          </a:xfrm>
+          <a:prstGeom prst="rect">
+            <a:avLst/>
+          </a:prstGeom>
+          <a:noFill/>
+        </p:spPr>
+        <p:txBody>
+          <a:bodyPr wrap="square" anchor="ctr">
+            <a:spAutoFit/>
+          </a:bodyPr>
+          <a:lstStyle/>
+          <a:p>
+            <a:pPr marL="177800" indent="-177800">
+              <a:spcBef>
+                <a:spcPts val="600"/>
+              </a:spcBef>
+              <a:spcAft>
+                <a:spcPts val="200"/>
+              </a:spcAft>
+            </a:pPr>
+            <a:r>
+              <a:rPr sz="1200" i="1">
+                <a:solidFill>
+                  <a:srgbClr val="3D5466"/>
+                </a:solidFill>
+                <a:latin typeface="Arial"/>
+              </a:rPr>
+              <a:t>→  Sorgfalt bei der Anlage ist kein Formalismus, sondern Schutz.</a:t>
+            </a:r>
+          </a:p>
+          <a:p>
+            <a:pPr marL="190500" indent="-190500">
+              <a:spcBef>
+                <a:spcPts val="400"/>
+              </a:spcBef>
+              <a:spcAft>
+                <a:spcPts val="200"/>
+              </a:spcAft>
+            </a:pPr>
+            <a:r>
+              <a:rPr sz="1300">
+                <a:solidFill>
+                  <a:srgbClr val="3D5466"/>
+                </a:solidFill>
+                <a:latin typeface="Arial"/>
+              </a:rPr>
+              <a:t>▸  Legitimation, Kontenwahrheit und Vertretungsberechtigung sauber zu prüfen verhindert Haftung und Geldwäsche.</a:t>
+            </a:r>
+          </a:p>
+        </p:txBody>
+      </p:sp>
+      <p:sp>
+        <p:nvSpPr>
+          <p:cNvPr id="9" name="Rectangle 8"/>
+          <p:cNvSpPr/>
+          <p:nvPr/>
+        </p:nvSpPr>
+        <p:spPr>
+          <a:xfrm>
+            <a:off x="0" y="6510528"/>
+            <a:ext cx="12188952" cy="347472"/>
+          </a:xfrm>
+          <a:prstGeom prst="rect">
+            <a:avLst/>
+          </a:prstGeom>
+          <a:solidFill>
+            <a:srgbClr val="0A1937"/>
+          </a:solidFill>
+          <a:ln>
+            <a:noFill/>
+          </a:ln>
+        </p:spPr>
+        <p:style>
+          <a:lnRef idx="1">
+            <a:schemeClr val="accent1"/>
+          </a:lnRef>
+          <a:fillRef idx="3">
+            <a:schemeClr val="accent1"/>
+          </a:fillRef>
+          <a:effectRef idx="2">
+            <a:schemeClr val="accent1"/>
+          </a:effectRef>
+          <a:fontRef idx="minor">
+            <a:schemeClr val="lt1"/>
+          </a:fontRef>
+        </p:style>
+        <p:txBody>
+          <a:bodyPr rtlCol="0" anchor="ctr"/>
+          <a:lstStyle/>
+          <a:p>
+            <a:pPr algn="ctr"/>
+          </a:p>
+        </p:txBody>
+      </p:sp>
+      <p:sp>
+        <p:nvSpPr>
+          <p:cNvPr id="10" name="TextBox 9"/>
+          <p:cNvSpPr txBox="1"/>
+          <p:nvPr/>
+        </p:nvSpPr>
+        <p:spPr>
+          <a:xfrm>
+            <a:off x="685800" y="6583680"/>
+            <a:ext cx="6490411" cy="256032"/>
+          </a:xfrm>
+          <a:prstGeom prst="rect">
+            <a:avLst/>
+          </a:prstGeom>
+          <a:noFill/>
+        </p:spPr>
+        <p:txBody>
+          <a:bodyPr wrap="none">
+            <a:spAutoFit/>
+          </a:bodyPr>
+          <a:lstStyle/>
+          <a:p>
+            <a:pPr algn="l"/>
+            <a:r>
+              <a:rPr sz="700">
+                <a:solidFill>
+                  <a:srgbClr val="A0B4D2"/>
+                </a:solidFill>
+                <a:latin typeface="Consolas"/>
+              </a:rPr>
+              <a:t>FKB Campus  ·  VA10</a:t>
+            </a:r>
+          </a:p>
+        </p:txBody>
+      </p:sp>
+    </p:spTree>
+  </p:cSld>
+  <p:clrMapOvr>
+    <a:masterClrMapping/>
+  </p:clrMapOvr>
+</p:sld>
+</file>
+
+<file path=ppt/slides/slide16.xml><?xml version="1.0" encoding="utf-8"?>
+<p:sld xmlns:a="http://schemas.openxmlformats.org/drawingml/2006/main" xmlns:p="http://schemas.openxmlformats.org/presentationml/2006/main" xmlns:r="http://schemas.openxmlformats.org/officeDocument/2006/relationships">
+  <p:cSld>
+    <p:spTree>
+      <p:nvGrpSpPr>
+        <p:cNvPr id="1" name=""/>
+        <p:cNvGrpSpPr/>
+        <p:nvPr/>
+      </p:nvGrpSpPr>
+      <p:grpSpPr/>
+      <p:sp>
+        <p:nvSpPr>
+          <p:cNvPr id="2" name="Rectangle 1"/>
+          <p:cNvSpPr/>
+          <p:nvPr/>
+        </p:nvSpPr>
+        <p:spPr>
+          <a:xfrm>
+            <a:off x="0" y="0"/>
+            <a:ext cx="12188952" cy="6858000"/>
+          </a:xfrm>
+          <a:prstGeom prst="rect">
+            <a:avLst/>
+          </a:prstGeom>
+          <a:solidFill>
+            <a:srgbClr val="EDEDF3"/>
+          </a:solidFill>
+          <a:ln>
+            <a:noFill/>
+          </a:ln>
+        </p:spPr>
+        <p:style>
+          <a:lnRef idx="1">
+            <a:schemeClr val="accent1"/>
+          </a:lnRef>
+          <a:fillRef idx="3">
+            <a:schemeClr val="accent1"/>
+          </a:fillRef>
+          <a:effectRef idx="2">
+            <a:schemeClr val="accent1"/>
+          </a:effectRef>
+          <a:fontRef idx="minor">
+            <a:schemeClr val="lt1"/>
+          </a:fontRef>
+        </p:style>
+        <p:txBody>
+          <a:bodyPr rtlCol="0" anchor="ctr"/>
+          <a:lstStyle/>
+          <a:p>
+            <a:pPr algn="ctr"/>
+          </a:p>
+        </p:txBody>
+      </p:sp>
+      <p:sp>
+        <p:nvSpPr>
+          <p:cNvPr id="3" name="Rectangle 2"/>
+          <p:cNvSpPr/>
+          <p:nvPr/>
+        </p:nvSpPr>
+        <p:spPr>
+          <a:xfrm>
+            <a:off x="0" y="0"/>
+            <a:ext cx="12188952" cy="50292"/>
+          </a:xfrm>
+          <a:prstGeom prst="rect">
+            <a:avLst/>
+          </a:prstGeom>
+          <a:solidFill>
+            <a:srgbClr val="1F2C56"/>
+          </a:solidFill>
+          <a:ln>
+            <a:noFill/>
+          </a:ln>
+        </p:spPr>
+        <p:style>
+          <a:lnRef idx="1">
+            <a:schemeClr val="accent1"/>
+          </a:lnRef>
+          <a:fillRef idx="3">
+            <a:schemeClr val="accent1"/>
+          </a:fillRef>
+          <a:effectRef idx="2">
+            <a:schemeClr val="accent1"/>
+          </a:effectRef>
+          <a:fontRef idx="minor">
+            <a:schemeClr val="lt1"/>
+          </a:fontRef>
+        </p:style>
+        <p:txBody>
+          <a:bodyPr rtlCol="0" anchor="ctr"/>
+          <a:lstStyle/>
+          <a:p>
+            <a:pPr algn="ctr"/>
+          </a:p>
+        </p:txBody>
+      </p:sp>
+      <p:sp>
+        <p:nvSpPr>
+          <p:cNvPr id="4" name="TextBox 3"/>
+          <p:cNvSpPr txBox="1"/>
+          <p:nvPr/>
+        </p:nvSpPr>
+        <p:spPr>
+          <a:xfrm>
+            <a:off x="685800" y="109728"/>
+            <a:ext cx="10817352" cy="228600"/>
+          </a:xfrm>
+          <a:prstGeom prst="rect">
+            <a:avLst/>
+          </a:prstGeom>
+          <a:noFill/>
+        </p:spPr>
+        <p:txBody>
+          <a:bodyPr wrap="none">
+            <a:spAutoFit/>
+          </a:bodyPr>
+          <a:lstStyle/>
+          <a:p>
+            <a:pPr algn="l"/>
+            <a:r>
+              <a:rPr sz="750">
+                <a:solidFill>
+                  <a:srgbClr val="78808C"/>
+                </a:solidFill>
+                <a:latin typeface="Consolas"/>
+              </a:rPr>
+              <a:t>VA10  ·  INHALT</a:t>
+            </a:r>
+          </a:p>
+        </p:txBody>
+      </p:sp>
+      <p:sp>
+        <p:nvSpPr>
+          <p:cNvPr id="5" name="Rectangle 4"/>
+          <p:cNvSpPr/>
+          <p:nvPr/>
+        </p:nvSpPr>
+        <p:spPr>
+          <a:xfrm>
+            <a:off x="0" y="1234440"/>
+            <a:ext cx="12188952" cy="12700"/>
+          </a:xfrm>
+          <a:prstGeom prst="rect">
+            <a:avLst/>
+          </a:prstGeom>
+          <a:solidFill>
+            <a:srgbClr val="D8DFE4"/>
+          </a:solidFill>
+          <a:ln>
+            <a:noFill/>
+          </a:ln>
+        </p:spPr>
+        <p:style>
+          <a:lnRef idx="1">
+            <a:schemeClr val="accent1"/>
+          </a:lnRef>
+          <a:fillRef idx="3">
+            <a:schemeClr val="accent1"/>
+          </a:fillRef>
+          <a:effectRef idx="2">
+            <a:schemeClr val="accent1"/>
+          </a:effectRef>
+          <a:fontRef idx="minor">
+            <a:schemeClr val="lt1"/>
+          </a:fontRef>
+        </p:style>
+        <p:txBody>
+          <a:bodyPr rtlCol="0" anchor="ctr"/>
+          <a:lstStyle/>
+          <a:p>
+            <a:pPr algn="ctr"/>
+          </a:p>
+        </p:txBody>
+      </p:sp>
+      <p:sp>
+        <p:nvSpPr>
+          <p:cNvPr id="6" name="Rectangle 5"/>
+          <p:cNvSpPr/>
+          <p:nvPr/>
+        </p:nvSpPr>
+        <p:spPr>
+          <a:xfrm>
+            <a:off x="685800" y="502920"/>
+            <a:ext cx="36576" cy="658368"/>
+          </a:xfrm>
+          <a:prstGeom prst="rect">
+            <a:avLst/>
+          </a:prstGeom>
+          <a:solidFill>
+            <a:srgbClr val="D9C089"/>
+          </a:solidFill>
+          <a:ln>
+            <a:noFill/>
+          </a:ln>
+        </p:spPr>
+        <p:style>
+          <a:lnRef idx="1">
+            <a:schemeClr val="accent1"/>
+          </a:lnRef>
+          <a:fillRef idx="3">
+            <a:schemeClr val="accent1"/>
+          </a:fillRef>
+          <a:effectRef idx="2">
+            <a:schemeClr val="accent1"/>
+          </a:effectRef>
+          <a:fontRef idx="minor">
+            <a:schemeClr val="lt1"/>
+          </a:fontRef>
+        </p:style>
+        <p:txBody>
+          <a:bodyPr rtlCol="0" anchor="ctr"/>
+          <a:lstStyle/>
+          <a:p>
+            <a:pPr algn="ctr"/>
+          </a:p>
+        </p:txBody>
+      </p:sp>
+      <p:sp>
+        <p:nvSpPr>
+          <p:cNvPr id="7" name="TextBox 6"/>
+          <p:cNvSpPr txBox="1"/>
+          <p:nvPr/>
+        </p:nvSpPr>
+        <p:spPr>
+          <a:xfrm>
+            <a:off x="813816" y="502920"/>
+            <a:ext cx="10634472" cy="685800"/>
+          </a:xfrm>
+          <a:prstGeom prst="rect">
+            <a:avLst/>
+          </a:prstGeom>
+          <a:noFill/>
+        </p:spPr>
+        <p:txBody>
+          <a:bodyPr wrap="square">
+            <a:spAutoFit/>
+          </a:bodyPr>
+          <a:lstStyle/>
+          <a:p>
+            <a:pPr algn="l"/>
+            <a:r>
+              <a:rPr sz="2400" b="1" i="0">
+                <a:solidFill>
+                  <a:srgbClr val="1F2C56"/>
+                </a:solidFill>
+                <a:latin typeface="Arial"/>
+              </a:rPr>
+              <a:t>Reflexionsfragen</a:t>
+            </a:r>
+          </a:p>
+        </p:txBody>
+      </p:sp>
+      <p:sp>
+        <p:nvSpPr>
+          <p:cNvPr id="8" name="TextBox 7"/>
+          <p:cNvSpPr txBox="1"/>
+          <p:nvPr/>
+        </p:nvSpPr>
+        <p:spPr>
+          <a:xfrm>
+            <a:off x="685800" y="1417320"/>
+            <a:ext cx="10817352" cy="4892040"/>
+          </a:xfrm>
+          <a:prstGeom prst="rect">
+            <a:avLst/>
+          </a:prstGeom>
+          <a:noFill/>
+        </p:spPr>
+        <p:txBody>
+          <a:bodyPr wrap="square" anchor="ctr">
+            <a:spAutoFit/>
+          </a:bodyPr>
+          <a:lstStyle/>
+          <a:p>
+            <a:pPr marL="190500" indent="-190500">
+              <a:spcBef>
+                <a:spcPts val="400"/>
+              </a:spcBef>
+              <a:spcAft>
+                <a:spcPts val="200"/>
+              </a:spcAft>
+            </a:pPr>
+            <a:r>
+              <a:rPr sz="1300">
+                <a:solidFill>
+                  <a:srgbClr val="3D5466"/>
+                </a:solidFill>
+                <a:latin typeface="Arial"/>
+              </a:rPr>
+              <a:t>▸  Bei welcher Rechtsform sind Sie sich bei der Vertretungsprüfung am unsichersten – und woran liegt das?</a:t>
+            </a:r>
+          </a:p>
+          <a:p>
+            <a:pPr marL="190500" indent="-190500">
+              <a:spcBef>
+                <a:spcPts val="400"/>
+              </a:spcBef>
+              <a:spcAft>
+                <a:spcPts val="200"/>
+              </a:spcAft>
+            </a:pPr>
+            <a:r>
+              <a:rPr sz="1300">
+                <a:solidFill>
+                  <a:srgbClr val="3D5466"/>
+                </a:solidFill>
+                <a:latin typeface="Arial"/>
+              </a:rPr>
+              <a:t>▸  Woran erkennen Sie im HR-Auszug den Unterschied zwischen Einzel- und Gesamtvertretung?</a:t>
+            </a:r>
+          </a:p>
+          <a:p>
+            <a:pPr marL="190500" indent="-190500">
+              <a:spcBef>
+                <a:spcPts val="400"/>
+              </a:spcBef>
+              <a:spcAft>
+                <a:spcPts val="200"/>
+              </a:spcAft>
+            </a:pPr>
+            <a:r>
+              <a:rPr sz="1300">
+                <a:solidFill>
+                  <a:srgbClr val="3D5466"/>
+                </a:solidFill>
+                <a:latin typeface="Arial"/>
+              </a:rPr>
+              <a:t>▸  Wann würden Sie eine Neuanlage stoppen und eskalieren, statt sie „später zu vervollständigen"?</a:t>
+            </a:r>
+          </a:p>
+        </p:txBody>
+      </p:sp>
+      <p:sp>
+        <p:nvSpPr>
+          <p:cNvPr id="9" name="Rectangle 8"/>
+          <p:cNvSpPr/>
+          <p:nvPr/>
+        </p:nvSpPr>
+        <p:spPr>
+          <a:xfrm>
+            <a:off x="0" y="6510528"/>
+            <a:ext cx="12188952" cy="347472"/>
+          </a:xfrm>
+          <a:prstGeom prst="rect">
+            <a:avLst/>
+          </a:prstGeom>
+          <a:solidFill>
+            <a:srgbClr val="0A1937"/>
+          </a:solidFill>
+          <a:ln>
+            <a:noFill/>
+          </a:ln>
+        </p:spPr>
+        <p:style>
+          <a:lnRef idx="1">
+            <a:schemeClr val="accent1"/>
+          </a:lnRef>
+          <a:fillRef idx="3">
+            <a:schemeClr val="accent1"/>
+          </a:fillRef>
+          <a:effectRef idx="2">
+            <a:schemeClr val="accent1"/>
+          </a:effectRef>
+          <a:fontRef idx="minor">
+            <a:schemeClr val="lt1"/>
+          </a:fontRef>
+        </p:style>
+        <p:txBody>
+          <a:bodyPr rtlCol="0" anchor="ctr"/>
+          <a:lstStyle/>
+          <a:p>
+            <a:pPr algn="ctr"/>
+          </a:p>
+        </p:txBody>
+      </p:sp>
+      <p:sp>
+        <p:nvSpPr>
+          <p:cNvPr id="10" name="TextBox 9"/>
+          <p:cNvSpPr txBox="1"/>
+          <p:nvPr/>
+        </p:nvSpPr>
+        <p:spPr>
+          <a:xfrm>
+            <a:off x="685800" y="6583680"/>
+            <a:ext cx="6490411" cy="256032"/>
+          </a:xfrm>
+          <a:prstGeom prst="rect">
+            <a:avLst/>
+          </a:prstGeom>
+          <a:noFill/>
+        </p:spPr>
+        <p:txBody>
+          <a:bodyPr wrap="none">
+            <a:spAutoFit/>
+          </a:bodyPr>
+          <a:lstStyle/>
+          <a:p>
+            <a:pPr algn="l"/>
+            <a:r>
+              <a:rPr sz="700">
+                <a:solidFill>
+                  <a:srgbClr val="A0B4D2"/>
+                </a:solidFill>
+                <a:latin typeface="Consolas"/>
+              </a:rPr>
+              <a:t>FKB Campus  ·  VA10</a:t>
+            </a:r>
+          </a:p>
+        </p:txBody>
+      </p:sp>
+    </p:spTree>
+  </p:cSld>
+  <p:clrMapOvr>
+    <a:masterClrMapping/>
+  </p:clrMapOvr>
+</p:sld>
+</file>
+
 <file path=ppt/slides/slide2.xml><?xml version="1.0" encoding="utf-8"?>
 <p:sld xmlns:a="http://schemas.openxmlformats.org/drawingml/2006/main" xmlns:p="http://schemas.openxmlformats.org/presentationml/2006/main" xmlns:r="http://schemas.openxmlformats.org/officeDocument/2006/relationships">
   <p:cSld>
@@ -5870,7 +8917,7 @@
             <a:avLst/>
           </a:prstGeom>
           <a:solidFill>
-            <a:srgbClr val="EDEDF3"/>
+            <a:srgbClr val="1F2C56"/>
           </a:solidFill>
           <a:ln>
             <a:noFill/>
@@ -5900,57 +8947,14 @@
       </p:sp>
       <p:sp>
         <p:nvSpPr>
-          <p:cNvPr id="3" name="Rectangle 2"/>
-          <p:cNvSpPr/>
-          <p:nvPr/>
-        </p:nvSpPr>
-        <p:spPr>
-          <a:xfrm>
-            <a:off x="0" y="0"/>
-            <a:ext cx="12188952" cy="50292"/>
-          </a:xfrm>
-          <a:prstGeom prst="rect">
-            <a:avLst/>
-          </a:prstGeom>
-          <a:solidFill>
-            <a:srgbClr val="1F2C56"/>
-          </a:solidFill>
-          <a:ln>
-            <a:noFill/>
-          </a:ln>
-        </p:spPr>
-        <p:style>
-          <a:lnRef idx="1">
-            <a:schemeClr val="accent1"/>
-          </a:lnRef>
-          <a:fillRef idx="3">
-            <a:schemeClr val="accent1"/>
-          </a:fillRef>
-          <a:effectRef idx="2">
-            <a:schemeClr val="accent1"/>
-          </a:effectRef>
-          <a:fontRef idx="minor">
-            <a:schemeClr val="lt1"/>
-          </a:fontRef>
-        </p:style>
-        <p:txBody>
-          <a:bodyPr rtlCol="0" anchor="ctr"/>
-          <a:lstStyle/>
-          <a:p>
-            <a:pPr algn="ctr"/>
-          </a:p>
-        </p:txBody>
-      </p:sp>
-      <p:sp>
-        <p:nvSpPr>
-          <p:cNvPr id="4" name="TextBox 3"/>
+          <p:cNvPr id="3" name="TextBox 2"/>
           <p:cNvSpPr txBox="1"/>
           <p:nvPr/>
         </p:nvSpPr>
         <p:spPr>
           <a:xfrm>
-            <a:off x="685800" y="109728"/>
-            <a:ext cx="10817352" cy="228600"/>
+            <a:off x="685800" y="2377440"/>
+            <a:ext cx="10817352" cy="365760"/>
           </a:xfrm>
           <a:prstGeom prst="rect">
             <a:avLst/>
@@ -5965,70 +8969,27 @@
           <a:p>
             <a:pPr algn="l"/>
             <a:r>
-              <a:rPr sz="750">
-                <a:solidFill>
-                  <a:srgbClr val="78808C"/>
+              <a:rPr sz="1200">
+                <a:solidFill>
+                  <a:srgbClr val="D9C089"/>
                 </a:solidFill>
                 <a:latin typeface="Consolas"/>
               </a:rPr>
-              <a:t>VA10  ·  INHALT</a:t>
-            </a:r>
-          </a:p>
-        </p:txBody>
-      </p:sp>
-      <p:sp>
-        <p:nvSpPr>
-          <p:cNvPr id="5" name="Rectangle 4"/>
+              <a:t>00:05–00:20</a:t>
+            </a:r>
+          </a:p>
+        </p:txBody>
+      </p:sp>
+      <p:sp>
+        <p:nvSpPr>
+          <p:cNvPr id="4" name="Rectangle 3"/>
           <p:cNvSpPr/>
           <p:nvPr/>
         </p:nvSpPr>
         <p:spPr>
           <a:xfrm>
-            <a:off x="0" y="1234440"/>
-            <a:ext cx="12188952" cy="12700"/>
-          </a:xfrm>
-          <a:prstGeom prst="rect">
-            <a:avLst/>
-          </a:prstGeom>
-          <a:solidFill>
-            <a:srgbClr val="D8DFE4"/>
-          </a:solidFill>
-          <a:ln>
-            <a:noFill/>
-          </a:ln>
-        </p:spPr>
-        <p:style>
-          <a:lnRef idx="1">
-            <a:schemeClr val="accent1"/>
-          </a:lnRef>
-          <a:fillRef idx="3">
-            <a:schemeClr val="accent1"/>
-          </a:fillRef>
-          <a:effectRef idx="2">
-            <a:schemeClr val="accent1"/>
-          </a:effectRef>
-          <a:fontRef idx="minor">
-            <a:schemeClr val="lt1"/>
-          </a:fontRef>
-        </p:style>
-        <p:txBody>
-          <a:bodyPr rtlCol="0" anchor="ctr"/>
-          <a:lstStyle/>
-          <a:p>
-            <a:pPr algn="ctr"/>
-          </a:p>
-        </p:txBody>
-      </p:sp>
-      <p:sp>
-        <p:nvSpPr>
-          <p:cNvPr id="6" name="Rectangle 5"/>
-          <p:cNvSpPr/>
-          <p:nvPr/>
-        </p:nvSpPr>
-        <p:spPr>
-          <a:xfrm>
-            <a:off x="685800" y="502920"/>
-            <a:ext cx="36576" cy="658368"/>
+            <a:off x="685800" y="2788920"/>
+            <a:ext cx="548640" cy="38100"/>
           </a:xfrm>
           <a:prstGeom prst="rect">
             <a:avLst/>
@@ -6064,14 +9025,14 @@
       </p:sp>
       <p:sp>
         <p:nvSpPr>
-          <p:cNvPr id="7" name="TextBox 6"/>
+          <p:cNvPr id="5" name="TextBox 4"/>
           <p:cNvSpPr txBox="1"/>
           <p:nvPr/>
         </p:nvSpPr>
         <p:spPr>
           <a:xfrm>
-            <a:off x="813816" y="502920"/>
-            <a:ext cx="10634472" cy="685800"/>
+            <a:off x="685800" y="3017520"/>
+            <a:ext cx="10817352" cy="1463040"/>
           </a:xfrm>
           <a:prstGeom prst="rect">
             <a:avLst/>
@@ -6086,27 +9047,27 @@
           <a:p>
             <a:pPr algn="l"/>
             <a:r>
-              <a:rPr sz="2400" b="1" i="0">
-                <a:solidFill>
-                  <a:srgbClr val="1F2C56"/>
+              <a:rPr sz="4000" b="1" i="0">
+                <a:solidFill>
+                  <a:srgbClr val="FFFFFF"/>
                 </a:solidFill>
                 <a:latin typeface="Arial"/>
               </a:rPr>
-              <a:t>Theorie-Input: Legitimation &amp; Kontenwahrheit – warum das Gesetz Klarheit verlangt</a:t>
-            </a:r>
-          </a:p>
-        </p:txBody>
-      </p:sp>
-      <p:sp>
-        <p:nvSpPr>
-          <p:cNvPr id="8" name="TextBox 7"/>
+              <a:t>Theorie-Input 1</a:t>
+            </a:r>
+          </a:p>
+        </p:txBody>
+      </p:sp>
+      <p:sp>
+        <p:nvSpPr>
+          <p:cNvPr id="6" name="TextBox 5"/>
           <p:cNvSpPr txBox="1"/>
           <p:nvPr/>
         </p:nvSpPr>
         <p:spPr>
           <a:xfrm>
-            <a:off x="685800" y="1417320"/>
-            <a:ext cx="10817352" cy="4892040"/>
+            <a:off x="685800" y="4480560"/>
+            <a:ext cx="8653881" cy="1280160"/>
           </a:xfrm>
           <a:prstGeom prst="rect">
             <a:avLst/>
@@ -6114,141 +9075,34 @@
           <a:noFill/>
         </p:spPr>
         <p:txBody>
-          <a:bodyPr wrap="square" anchor="ctr">
+          <a:bodyPr wrap="square">
             <a:spAutoFit/>
           </a:bodyPr>
           <a:lstStyle/>
           <a:p>
-            <a:pPr marL="177800" indent="-177800">
-              <a:spcBef>
-                <a:spcPts val="600"/>
-              </a:spcBef>
-              <a:spcAft>
-                <a:spcPts val="200"/>
-              </a:spcAft>
-            </a:pPr>
-            <a:r>
-              <a:rPr sz="1200" i="1">
-                <a:solidFill>
-                  <a:srgbClr val="3D5466"/>
+            <a:pPr algn="l"/>
+            <a:r>
+              <a:rPr sz="1600" b="0" i="0">
+                <a:solidFill>
+                  <a:srgbClr val="C8D2E6"/>
                 </a:solidFill>
                 <a:latin typeface="Arial"/>
               </a:rPr>
-              <a:t>→  Praxishinweis – Wo wird legitimiert und dokumentiert?</a:t>
-            </a:r>
-          </a:p>
-          <a:p>
-            <a:pPr marL="177800" indent="-177800">
-              <a:spcBef>
-                <a:spcPts val="600"/>
-              </a:spcBef>
-              <a:spcAft>
-                <a:spcPts val="200"/>
-              </a:spcAft>
-            </a:pPr>
-            <a:r>
-              <a:rPr sz="1200" i="1">
-                <a:solidFill>
-                  <a:srgbClr val="3D5466"/>
-                </a:solidFill>
-                <a:latin typeface="Arial"/>
-              </a:rPr>
-              <a:t>→  Handlungsempfehlung</a:t>
-            </a:r>
-          </a:p>
-          <a:p>
-            <a:pPr marL="177800" indent="-177800">
-              <a:spcBef>
-                <a:spcPts val="600"/>
-              </a:spcBef>
-              <a:spcAft>
-                <a:spcPts val="200"/>
-              </a:spcAft>
-            </a:pPr>
-            <a:r>
-              <a:rPr sz="1200" i="1">
-                <a:solidFill>
-                  <a:srgbClr val="3D5466"/>
-                </a:solidFill>
-                <a:latin typeface="Arial"/>
-              </a:rPr>
-              <a:t>→  Wenn bei einer Kontoeröffnung für eine juristische Person kein aktueller Registerauszug vorliegt</a:t>
-            </a:r>
-          </a:p>
-          <a:p>
-            <a:pPr marL="177800" indent="-177800">
-              <a:spcBef>
-                <a:spcPts val="600"/>
-              </a:spcBef>
-              <a:spcAft>
-                <a:spcPts val="200"/>
-              </a:spcAft>
-            </a:pPr>
-            <a:r>
-              <a:rPr sz="1200" i="1">
-                <a:solidFill>
-                  <a:srgbClr val="3D5466"/>
-                </a:solidFill>
-                <a:latin typeface="Arial"/>
-              </a:rPr>
-              <a:t>→  Dann Anlage im System stoppen und den zuständigen Berater informieren – kein Konto ohne vollständige Legitimationsunterlagen eröffnen</a:t>
-            </a:r>
-          </a:p>
-        </p:txBody>
-      </p:sp>
-      <p:sp>
-        <p:nvSpPr>
-          <p:cNvPr id="9" name="Rectangle 8"/>
-          <p:cNvSpPr/>
-          <p:nvPr/>
-        </p:nvSpPr>
-        <p:spPr>
-          <a:xfrm>
-            <a:off x="0" y="6510528"/>
-            <a:ext cx="12188952" cy="347472"/>
-          </a:xfrm>
-          <a:prstGeom prst="rect">
-            <a:avLst/>
-          </a:prstGeom>
-          <a:solidFill>
-            <a:srgbClr val="0A1937"/>
-          </a:solidFill>
-          <a:ln>
-            <a:noFill/>
-          </a:ln>
-        </p:spPr>
-        <p:style>
-          <a:lnRef idx="1">
-            <a:schemeClr val="accent1"/>
-          </a:lnRef>
-          <a:fillRef idx="3">
-            <a:schemeClr val="accent1"/>
-          </a:fillRef>
-          <a:effectRef idx="2">
-            <a:schemeClr val="accent1"/>
-          </a:effectRef>
-          <a:fontRef idx="minor">
-            <a:schemeClr val="lt1"/>
-          </a:fontRef>
-        </p:style>
-        <p:txBody>
-          <a:bodyPr rtlCol="0" anchor="ctr"/>
-          <a:lstStyle/>
-          <a:p>
-            <a:pPr algn="ctr"/>
-          </a:p>
-        </p:txBody>
-      </p:sp>
-      <p:sp>
-        <p:nvSpPr>
-          <p:cNvPr id="10" name="TextBox 9"/>
+              <a:t>Legitimation und Kontenwahrheit – die formalen Pflichten bei der Anlage.</a:t>
+            </a:r>
+          </a:p>
+        </p:txBody>
+      </p:sp>
+      <p:sp>
+        <p:nvSpPr>
+          <p:cNvPr id="7" name="TextBox 6"/>
           <p:cNvSpPr txBox="1"/>
           <p:nvPr/>
         </p:nvSpPr>
         <p:spPr>
           <a:xfrm>
-            <a:off x="685800" y="6583680"/>
-            <a:ext cx="6490411" cy="256032"/>
+            <a:off x="685800" y="6355080"/>
+            <a:ext cx="10817352" cy="274320"/>
           </a:xfrm>
           <a:prstGeom prst="rect">
             <a:avLst/>
@@ -6265,7 +9119,7 @@
             <a:r>
               <a:rPr sz="700">
                 <a:solidFill>
-                  <a:srgbClr val="A0B4D2"/>
+                  <a:srgbClr val="8CA0C3"/>
                 </a:solidFill>
                 <a:latin typeface="Consolas"/>
               </a:rPr>
@@ -6529,7 +9383,7 @@
                 </a:solidFill>
                 <a:latin typeface="Arial"/>
               </a:rPr>
-              <a:t>Theorie-Input: Vertretungsberechtigung – wer darf für das Unternehmen handeln?</a:t>
+              <a:t>Neukundenanlage: Legitimation und Kontenwahrheit</a:t>
             </a:r>
           </a:p>
         </p:txBody>
@@ -6551,10 +9405,29 @@
           <a:noFill/>
         </p:spPr>
         <p:txBody>
-          <a:bodyPr wrap="square">
+          <a:bodyPr wrap="square" anchor="ctr">
             <a:spAutoFit/>
           </a:bodyPr>
           <a:lstStyle/>
+          <a:p>
+            <a:pPr marL="177800" indent="-177800">
+              <a:spcBef>
+                <a:spcPts val="600"/>
+              </a:spcBef>
+              <a:spcAft>
+                <a:spcPts val="200"/>
+              </a:spcAft>
+            </a:pPr>
+            <a:r>
+              <a:rPr sz="1200" i="1">
+                <a:solidFill>
+                  <a:srgbClr val="3D5466"/>
+                </a:solidFill>
+                <a:latin typeface="Arial"/>
+              </a:rPr>
+              <a:t>→  Kein Konto ohne vollständige Legitimationsunterlagen – Sorgfalt bei der Anlage ist kein Formalismus, sondern Schutz vor Haftung und Geldwäsche.</a:t>
+            </a:r>
+          </a:p>
           <a:p>
             <a:pPr marL="190500" indent="-190500">
               <a:spcBef>
@@ -6571,121 +9444,45 @@
                 </a:solidFill>
                 <a:latin typeface="Arial"/>
               </a:rPr>
-              <a:t>▸  Übersicht: Vertretungsregelungen nach Rechtsform</a:t>
-            </a:r>
-          </a:p>
-          <a:p>
-            <a:pPr marL="177800" indent="-177800">
+              <a:t>▸  Kontenwahrheit (§ 154 AO): kein falscher oder erfundener Name; der richtige Kontoinhaber.</a:t>
+            </a:r>
+          </a:p>
+          <a:p>
+            <a:pPr marL="190500" indent="-190500">
               <a:spcBef>
-                <a:spcPts val="600"/>
+                <a:spcPts val="400"/>
               </a:spcBef>
               <a:spcAft>
                 <a:spcPts val="200"/>
               </a:spcAft>
             </a:pPr>
             <a:r>
-              <a:rPr sz="1200" i="1">
+              <a:rPr sz="1300">
                 <a:solidFill>
                   <a:srgbClr val="3D5466"/>
                 </a:solidFill>
                 <a:latin typeface="Arial"/>
               </a:rPr>
-              <a:t>→  Handlungsempfehlung</a:t>
-            </a:r>
-          </a:p>
-          <a:p>
-            <a:pPr marL="177800" indent="-177800">
+              <a:t>▸  Identifizierung (§§ 10–11 GwG): Identifizierungspflicht mit zulässigen Verifizierungsmitteln.</a:t>
+            </a:r>
+          </a:p>
+          <a:p>
+            <a:pPr marL="190500" indent="-190500">
               <a:spcBef>
-                <a:spcPts val="600"/>
+                <a:spcPts val="400"/>
               </a:spcBef>
               <a:spcAft>
                 <a:spcPts val="200"/>
               </a:spcAft>
             </a:pPr>
             <a:r>
-              <a:rPr sz="1200" i="1">
+              <a:rPr sz="1300">
                 <a:solidFill>
                   <a:srgbClr val="3D5466"/>
                 </a:solidFill>
                 <a:latin typeface="Arial"/>
               </a:rPr>
-              <a:t>→  Wenn ein Handelsregisterauszug Gesamtvertretung ausweist und nur eine Unterschrift vorliegt</a:t>
-            </a:r>
-          </a:p>
-          <a:p>
-            <a:pPr marL="177800" indent="-177800">
-              <a:spcBef>
-                <a:spcPts val="600"/>
-              </a:spcBef>
-              <a:spcAft>
-                <a:spcPts val="200"/>
-              </a:spcAft>
-            </a:pPr>
-            <a:r>
-              <a:rPr sz="1200" i="1">
-                <a:solidFill>
-                  <a:srgbClr val="3D5466"/>
-                </a:solidFill>
-                <a:latin typeface="Arial"/>
-              </a:rPr>
-              <a:t>→  Dann Unterschrift sofort als unvollständig kennzeichnen, Berater informieren und Nachzeichnung veranlassen – das Dokument ist so nicht rechtswirksam</a:t>
-            </a:r>
-          </a:p>
-          <a:p>
-            <a:pPr marL="177800" indent="-177800">
-              <a:spcBef>
-                <a:spcPts val="600"/>
-              </a:spcBef>
-              <a:spcAft>
-                <a:spcPts val="200"/>
-              </a:spcAft>
-            </a:pPr>
-            <a:r>
-              <a:rPr sz="1200" i="1">
-                <a:solidFill>
-                  <a:srgbClr val="3D5466"/>
-                </a:solidFill>
-                <a:latin typeface="Arial"/>
-              </a:rPr>
-              <a:t>→  Handlungsempfehlung</a:t>
-            </a:r>
-          </a:p>
-          <a:p>
-            <a:pPr marL="177800" indent="-177800">
-              <a:spcBef>
-                <a:spcPts val="600"/>
-              </a:spcBef>
-              <a:spcAft>
-                <a:spcPts val="200"/>
-              </a:spcAft>
-            </a:pPr>
-            <a:r>
-              <a:rPr sz="1200" i="1">
-                <a:solidFill>
-                  <a:srgbClr val="3D5466"/>
-                </a:solidFill>
-                <a:latin typeface="Arial"/>
-              </a:rPr>
-              <a:t>→  Wenn der Handelsregisterauszug älter als 3 Monate ist</a:t>
-            </a:r>
-          </a:p>
-          <a:p>
-            <a:pPr marL="177800" indent="-177800">
-              <a:spcBef>
-                <a:spcPts val="600"/>
-              </a:spcBef>
-              <a:spcAft>
-                <a:spcPts val="200"/>
-              </a:spcAft>
-            </a:pPr>
-            <a:r>
-              <a:rPr sz="1200" i="1">
-                <a:solidFill>
-                  <a:srgbClr val="3D5466"/>
-                </a:solidFill>
-                <a:latin typeface="Arial"/>
-              </a:rPr>
-              <a:t>→  Dann aktuellen Auszug über www.handelsregister.de abrufen oder den Kunden um Vorlage bitten – Vertretungsverhältnisse können sich geändert haben</a:t>
+              <a:t>▸  Transparenzregister-Nachweis einholen; die Sachbearbeitung prüft formal, nicht inhaltlich.</a:t>
             </a:r>
           </a:p>
         </p:txBody>
@@ -6801,7 +9598,7 @@
             <a:avLst/>
           </a:prstGeom>
           <a:solidFill>
-            <a:srgbClr val="EDEDF3"/>
+            <a:srgbClr val="FFFFFF"/>
           </a:solidFill>
           <a:ln>
             <a:noFill/>
@@ -6902,51 +9699,43 @@
                 </a:solidFill>
                 <a:latin typeface="Consolas"/>
               </a:rPr>
-              <a:t>VA10  ·  ARBEITSBLATT</a:t>
-            </a:r>
-          </a:p>
-        </p:txBody>
-      </p:sp>
-      <p:sp>
-        <p:nvSpPr>
-          <p:cNvPr id="5" name="Rectangle 4"/>
-          <p:cNvSpPr/>
-          <p:nvPr/>
-        </p:nvSpPr>
-        <p:spPr>
-          <a:xfrm>
-            <a:off x="0" y="1234440"/>
-            <a:ext cx="12188952" cy="12700"/>
-          </a:xfrm>
-          <a:prstGeom prst="rect">
-            <a:avLst/>
-          </a:prstGeom>
-          <a:solidFill>
-            <a:srgbClr val="D8DFE4"/>
-          </a:solidFill>
-          <a:ln>
-            <a:noFill/>
-          </a:ln>
-        </p:spPr>
-        <p:style>
-          <a:lnRef idx="1">
-            <a:schemeClr val="accent1"/>
-          </a:lnRef>
-          <a:fillRef idx="3">
-            <a:schemeClr val="accent1"/>
-          </a:fillRef>
-          <a:effectRef idx="2">
-            <a:schemeClr val="accent1"/>
-          </a:effectRef>
-          <a:fontRef idx="minor">
-            <a:schemeClr val="lt1"/>
-          </a:fontRef>
-        </p:style>
-        <p:txBody>
-          <a:bodyPr rtlCol="0" anchor="ctr"/>
-          <a:lstStyle/>
-          <a:p>
-            <a:pPr algn="ctr"/>
+              <a:t>VA10  ·  SCHAUBILD</a:t>
+            </a:r>
+          </a:p>
+        </p:txBody>
+      </p:sp>
+      <p:sp>
+        <p:nvSpPr>
+          <p:cNvPr id="5" name="TextBox 4"/>
+          <p:cNvSpPr txBox="1"/>
+          <p:nvPr/>
+        </p:nvSpPr>
+        <p:spPr>
+          <a:xfrm>
+            <a:off x="685800" y="502920"/>
+            <a:ext cx="10817352" cy="594360"/>
+          </a:xfrm>
+          <a:prstGeom prst="rect">
+            <a:avLst/>
+          </a:prstGeom>
+          <a:noFill/>
+        </p:spPr>
+        <p:txBody>
+          <a:bodyPr wrap="square">
+            <a:spAutoFit/>
+          </a:bodyPr>
+          <a:lstStyle/>
+          <a:p>
+            <a:pPr algn="l"/>
+            <a:r>
+              <a:rPr sz="2000" b="1" i="0">
+                <a:solidFill>
+                  <a:srgbClr val="1F2C56"/>
+                </a:solidFill>
+                <a:latin typeface="Arial"/>
+              </a:rPr>
+              <a:t>Drei Säulen der Legitimationsprüfung</a:t>
+            </a:r>
           </a:p>
         </p:txBody>
       </p:sp>
@@ -6958,8 +9747,8 @@
         </p:nvSpPr>
         <p:spPr>
           <a:xfrm>
-            <a:off x="685800" y="502920"/>
-            <a:ext cx="36576" cy="658368"/>
+            <a:off x="685800" y="1143000"/>
+            <a:ext cx="10817352" cy="25400"/>
           </a:xfrm>
           <a:prstGeom prst="rect">
             <a:avLst/>
@@ -6993,240 +9782,33 @@
           </a:p>
         </p:txBody>
       </p:sp>
-      <p:sp>
-        <p:nvSpPr>
-          <p:cNvPr id="7" name="TextBox 6"/>
-          <p:cNvSpPr txBox="1"/>
-          <p:nvPr/>
-        </p:nvSpPr>
-        <p:spPr>
-          <a:xfrm>
-            <a:off x="813816" y="502920"/>
-            <a:ext cx="10634472" cy="685800"/>
-          </a:xfrm>
-          <a:prstGeom prst="rect">
-            <a:avLst/>
-          </a:prstGeom>
-          <a:noFill/>
-        </p:spPr>
-        <p:txBody>
-          <a:bodyPr wrap="square">
-            <a:spAutoFit/>
-          </a:bodyPr>
-          <a:lstStyle/>
-          <a:p>
-            <a:pPr algn="l"/>
-            <a:r>
-              <a:rPr sz="2400" b="1" i="0">
-                <a:solidFill>
-                  <a:srgbClr val="1F2C56"/>
-                </a:solidFill>
-                <a:latin typeface="Arial"/>
-              </a:rPr>
-              <a:t>Praxisfall: Neuanlage Tischler-Meistermarkt Musterregion GmbH &amp; Co. KG</a:t>
-            </a:r>
-          </a:p>
-        </p:txBody>
-      </p:sp>
-      <p:sp>
-        <p:nvSpPr>
-          <p:cNvPr id="8" name="TextBox 7"/>
-          <p:cNvSpPr txBox="1"/>
-          <p:nvPr/>
-        </p:nvSpPr>
-        <p:spPr>
-          <a:xfrm>
-            <a:off x="685800" y="1554480"/>
-            <a:ext cx="10817352" cy="3840480"/>
-          </a:xfrm>
-          <a:prstGeom prst="rect">
-            <a:avLst/>
-          </a:prstGeom>
-          <a:noFill/>
-        </p:spPr>
-        <p:txBody>
-          <a:bodyPr wrap="square">
-            <a:spAutoFit/>
-          </a:bodyPr>
-          <a:lstStyle/>
-          <a:p>
-            <a:pPr marL="190500" indent="-190500">
-              <a:spcBef>
-                <a:spcPts val="400"/>
-              </a:spcBef>
-              <a:spcAft>
-                <a:spcPts val="200"/>
-              </a:spcAft>
-            </a:pPr>
-            <a:r>
-              <a:rPr sz="1400">
-                <a:solidFill>
-                  <a:srgbClr val="3D5466"/>
-                </a:solidFill>
-                <a:latin typeface="Arial"/>
-              </a:rPr>
-              <a:t>▸  Unternehmensportrait (anonymisiert, branchentypisch)</a:t>
-            </a:r>
-          </a:p>
-          <a:p>
-            <a:pPr marL="190500" indent="-190500">
-              <a:spcBef>
-                <a:spcPts val="400"/>
-              </a:spcBef>
-              <a:spcAft>
-                <a:spcPts val="200"/>
-              </a:spcAft>
-            </a:pPr>
-            <a:r>
-              <a:rPr sz="1400">
-                <a:solidFill>
-                  <a:srgbClr val="3D5466"/>
-                </a:solidFill>
-                <a:latin typeface="Arial"/>
-              </a:rPr>
-              <a:t>▸  Vorgelegte Unterlagen:</a:t>
-            </a:r>
-          </a:p>
-          <a:p>
-            <a:pPr marL="190500" indent="-190500">
-              <a:spcBef>
-                <a:spcPts val="400"/>
-              </a:spcBef>
-              <a:spcAft>
-                <a:spcPts val="200"/>
-              </a:spcAft>
-            </a:pPr>
-            <a:r>
-              <a:rPr sz="1400">
-                <a:solidFill>
-                  <a:srgbClr val="3D5466"/>
-                </a:solidFill>
-                <a:latin typeface="Arial"/>
-              </a:rPr>
-              <a:t>▸  HR-Auszug KG (Auszug, vereinfacht):</a:t>
-            </a:r>
-          </a:p>
-          <a:p>
-            <a:pPr marL="190500" indent="-190500">
-              <a:spcBef>
-                <a:spcPts val="400"/>
-              </a:spcBef>
-              <a:spcAft>
-                <a:spcPts val="200"/>
-              </a:spcAft>
-            </a:pPr>
-            <a:r>
-              <a:rPr sz="1400">
-                <a:solidFill>
-                  <a:srgbClr val="3D5466"/>
-                </a:solidFill>
-                <a:latin typeface="Arial"/>
-              </a:rPr>
-              <a:t>▸  HR-Auszug GmbH (Auszug, vereinfacht):</a:t>
-            </a:r>
-          </a:p>
-          <a:p>
-            <a:pPr marL="190500" indent="-190500">
-              <a:spcBef>
-                <a:spcPts val="400"/>
-              </a:spcBef>
-              <a:spcAft>
-                <a:spcPts val="200"/>
-              </a:spcAft>
-            </a:pPr>
-            <a:r>
-              <a:rPr sz="1400">
-                <a:solidFill>
-                  <a:srgbClr val="3D5466"/>
-                </a:solidFill>
-                <a:latin typeface="Arial"/>
-              </a:rPr>
-              <a:t>▸  Analyse:</a:t>
-            </a:r>
-          </a:p>
-        </p:txBody>
-      </p:sp>
-      <p:sp>
-        <p:nvSpPr>
-          <p:cNvPr id="9" name="Rectangle 8"/>
-          <p:cNvSpPr/>
-          <p:nvPr/>
-        </p:nvSpPr>
-        <p:spPr>
-          <a:xfrm>
-            <a:off x="685800" y="5486400"/>
-            <a:ext cx="10817352" cy="640080"/>
-          </a:xfrm>
-          <a:prstGeom prst="rect">
-            <a:avLst/>
-          </a:prstGeom>
-          <a:solidFill>
-            <a:srgbClr val="1F2C56"/>
-          </a:solidFill>
-          <a:ln>
-            <a:noFill/>
-          </a:ln>
-        </p:spPr>
-        <p:style>
-          <a:lnRef idx="1">
-            <a:schemeClr val="accent1"/>
-          </a:lnRef>
-          <a:fillRef idx="3">
-            <a:schemeClr val="accent1"/>
-          </a:fillRef>
-          <a:effectRef idx="2">
-            <a:schemeClr val="accent1"/>
-          </a:effectRef>
-          <a:fontRef idx="minor">
-            <a:schemeClr val="lt1"/>
-          </a:fontRef>
-        </p:style>
-        <p:txBody>
-          <a:bodyPr rtlCol="0" anchor="ctr"/>
-          <a:lstStyle/>
-          <a:p>
-            <a:pPr algn="ctr"/>
-          </a:p>
-        </p:txBody>
-      </p:sp>
-      <p:sp>
-        <p:nvSpPr>
-          <p:cNvPr id="10" name="TextBox 9"/>
-          <p:cNvSpPr txBox="1"/>
-          <p:nvPr/>
-        </p:nvSpPr>
-        <p:spPr>
-          <a:xfrm>
-            <a:off x="868680" y="5596128"/>
-            <a:ext cx="10451592" cy="457200"/>
-          </a:xfrm>
-          <a:prstGeom prst="rect">
-            <a:avLst/>
-          </a:prstGeom>
-          <a:noFill/>
-        </p:spPr>
-        <p:txBody>
-          <a:bodyPr wrap="square">
-            <a:spAutoFit/>
-          </a:bodyPr>
-          <a:lstStyle/>
-          <a:p>
-            <a:pPr algn="l"/>
-            <a:r>
-              <a:rPr sz="1300" b="1" i="0">
-                <a:solidFill>
-                  <a:srgbClr val="FFFFFF"/>
-                </a:solidFill>
-                <a:latin typeface="Arial"/>
-              </a:rPr>
-              <a:t>→  Bearbeitung im Teilnehmer-Workbook (Arbeitsblatt mit Ausfüllfeldern)</a:t>
-            </a:r>
-          </a:p>
-        </p:txBody>
-      </p:sp>
-      <p:sp>
-        <p:nvSpPr>
-          <p:cNvPr id="11" name="Rectangle 10"/>
+      <p:pic>
+        <p:nvPicPr>
+          <p:cNvPr id="7" name="Picture 6" descr="image.png"/>
+          <p:cNvPicPr>
+            <a:picLocks noChangeAspect="1"/>
+          </p:cNvPicPr>
+          <p:nvPr/>
+        </p:nvPicPr>
+        <p:blipFill>
+          <a:blip r:embed="rId2"/>
+          <a:stretch>
+            <a:fillRect/>
+          </a:stretch>
+        </p:blipFill>
+        <p:spPr>
+          <a:xfrm>
+            <a:off x="2009463" y="1325880"/>
+            <a:ext cx="8170026" cy="4937760"/>
+          </a:xfrm>
+          <a:prstGeom prst="rect">
+            <a:avLst/>
+          </a:prstGeom>
+        </p:spPr>
+      </p:pic>
+      <p:sp>
+        <p:nvSpPr>
+          <p:cNvPr id="8" name="Rectangle 7"/>
           <p:cNvSpPr/>
           <p:nvPr/>
         </p:nvSpPr>
@@ -7269,7 +9851,7 @@
       </p:sp>
       <p:sp>
         <p:nvSpPr>
-          <p:cNvPr id="12" name="TextBox 11"/>
+          <p:cNvPr id="9" name="TextBox 8"/>
           <p:cNvSpPr txBox="1"/>
           <p:nvPr/>
         </p:nvSpPr>
@@ -7298,6 +9880,41 @@
                 <a:latin typeface="Consolas"/>
               </a:rPr>
               <a:t>FKB Campus  ·  VA10</a:t>
+            </a:r>
+          </a:p>
+        </p:txBody>
+      </p:sp>
+      <p:sp>
+        <p:nvSpPr>
+          <p:cNvPr id="10" name="TextBox 9"/>
+          <p:cNvSpPr txBox="1"/>
+          <p:nvPr/>
+        </p:nvSpPr>
+        <p:spPr>
+          <a:xfrm>
+            <a:off x="7176211" y="6583680"/>
+            <a:ext cx="4326940" cy="256032"/>
+          </a:xfrm>
+          <a:prstGeom prst="rect">
+            <a:avLst/>
+          </a:prstGeom>
+          <a:noFill/>
+        </p:spPr>
+        <p:txBody>
+          <a:bodyPr wrap="none">
+            <a:spAutoFit/>
+          </a:bodyPr>
+          <a:lstStyle/>
+          <a:p>
+            <a:pPr algn="r"/>
+            <a:r>
+              <a:rPr sz="700">
+                <a:solidFill>
+                  <a:srgbClr val="A0B4D2"/>
+                </a:solidFill>
+                <a:latin typeface="Consolas"/>
+              </a:rPr>
+              <a:t>Schaubild</a:t>
             </a:r>
           </a:p>
         </p:txBody>
@@ -7335,6 +9952,250 @@
             <a:avLst/>
           </a:prstGeom>
           <a:solidFill>
+            <a:srgbClr val="1F2C56"/>
+          </a:solidFill>
+          <a:ln>
+            <a:noFill/>
+          </a:ln>
+        </p:spPr>
+        <p:style>
+          <a:lnRef idx="1">
+            <a:schemeClr val="accent1"/>
+          </a:lnRef>
+          <a:fillRef idx="3">
+            <a:schemeClr val="accent1"/>
+          </a:fillRef>
+          <a:effectRef idx="2">
+            <a:schemeClr val="accent1"/>
+          </a:effectRef>
+          <a:fontRef idx="minor">
+            <a:schemeClr val="lt1"/>
+          </a:fontRef>
+        </p:style>
+        <p:txBody>
+          <a:bodyPr rtlCol="0" anchor="ctr"/>
+          <a:lstStyle/>
+          <a:p>
+            <a:pPr algn="ctr"/>
+          </a:p>
+        </p:txBody>
+      </p:sp>
+      <p:sp>
+        <p:nvSpPr>
+          <p:cNvPr id="3" name="TextBox 2"/>
+          <p:cNvSpPr txBox="1"/>
+          <p:nvPr/>
+        </p:nvSpPr>
+        <p:spPr>
+          <a:xfrm>
+            <a:off x="685800" y="2377440"/>
+            <a:ext cx="10817352" cy="365760"/>
+          </a:xfrm>
+          <a:prstGeom prst="rect">
+            <a:avLst/>
+          </a:prstGeom>
+          <a:noFill/>
+        </p:spPr>
+        <p:txBody>
+          <a:bodyPr wrap="none">
+            <a:spAutoFit/>
+          </a:bodyPr>
+          <a:lstStyle/>
+          <a:p>
+            <a:pPr algn="l"/>
+            <a:r>
+              <a:rPr sz="1200">
+                <a:solidFill>
+                  <a:srgbClr val="D9C089"/>
+                </a:solidFill>
+                <a:latin typeface="Consolas"/>
+              </a:rPr>
+              <a:t>00:20–00:35</a:t>
+            </a:r>
+          </a:p>
+        </p:txBody>
+      </p:sp>
+      <p:sp>
+        <p:nvSpPr>
+          <p:cNvPr id="4" name="Rectangle 3"/>
+          <p:cNvSpPr/>
+          <p:nvPr/>
+        </p:nvSpPr>
+        <p:spPr>
+          <a:xfrm>
+            <a:off x="685800" y="2788920"/>
+            <a:ext cx="548640" cy="38100"/>
+          </a:xfrm>
+          <a:prstGeom prst="rect">
+            <a:avLst/>
+          </a:prstGeom>
+          <a:solidFill>
+            <a:srgbClr val="D9C089"/>
+          </a:solidFill>
+          <a:ln>
+            <a:noFill/>
+          </a:ln>
+        </p:spPr>
+        <p:style>
+          <a:lnRef idx="1">
+            <a:schemeClr val="accent1"/>
+          </a:lnRef>
+          <a:fillRef idx="3">
+            <a:schemeClr val="accent1"/>
+          </a:fillRef>
+          <a:effectRef idx="2">
+            <a:schemeClr val="accent1"/>
+          </a:effectRef>
+          <a:fontRef idx="minor">
+            <a:schemeClr val="lt1"/>
+          </a:fontRef>
+        </p:style>
+        <p:txBody>
+          <a:bodyPr rtlCol="0" anchor="ctr"/>
+          <a:lstStyle/>
+          <a:p>
+            <a:pPr algn="ctr"/>
+          </a:p>
+        </p:txBody>
+      </p:sp>
+      <p:sp>
+        <p:nvSpPr>
+          <p:cNvPr id="5" name="TextBox 4"/>
+          <p:cNvSpPr txBox="1"/>
+          <p:nvPr/>
+        </p:nvSpPr>
+        <p:spPr>
+          <a:xfrm>
+            <a:off x="685800" y="3017520"/>
+            <a:ext cx="10817352" cy="1463040"/>
+          </a:xfrm>
+          <a:prstGeom prst="rect">
+            <a:avLst/>
+          </a:prstGeom>
+          <a:noFill/>
+        </p:spPr>
+        <p:txBody>
+          <a:bodyPr wrap="square">
+            <a:spAutoFit/>
+          </a:bodyPr>
+          <a:lstStyle/>
+          <a:p>
+            <a:pPr algn="l"/>
+            <a:r>
+              <a:rPr sz="4000" b="1" i="0">
+                <a:solidFill>
+                  <a:srgbClr val="FFFFFF"/>
+                </a:solidFill>
+                <a:latin typeface="Arial"/>
+              </a:rPr>
+              <a:t>Theorie-Input 2</a:t>
+            </a:r>
+          </a:p>
+        </p:txBody>
+      </p:sp>
+      <p:sp>
+        <p:nvSpPr>
+          <p:cNvPr id="6" name="TextBox 5"/>
+          <p:cNvSpPr txBox="1"/>
+          <p:nvPr/>
+        </p:nvSpPr>
+        <p:spPr>
+          <a:xfrm>
+            <a:off x="685800" y="4480560"/>
+            <a:ext cx="8653881" cy="1280160"/>
+          </a:xfrm>
+          <a:prstGeom prst="rect">
+            <a:avLst/>
+          </a:prstGeom>
+          <a:noFill/>
+        </p:spPr>
+        <p:txBody>
+          <a:bodyPr wrap="square">
+            <a:spAutoFit/>
+          </a:bodyPr>
+          <a:lstStyle/>
+          <a:p>
+            <a:pPr algn="l"/>
+            <a:r>
+              <a:rPr sz="1600" b="0" i="0">
+                <a:solidFill>
+                  <a:srgbClr val="C8D2E6"/>
+                </a:solidFill>
+                <a:latin typeface="Arial"/>
+              </a:rPr>
+              <a:t>Wer darf für das Unternehmen handeln? Vertretung nach Rechtsform.</a:t>
+            </a:r>
+          </a:p>
+        </p:txBody>
+      </p:sp>
+      <p:sp>
+        <p:nvSpPr>
+          <p:cNvPr id="7" name="TextBox 6"/>
+          <p:cNvSpPr txBox="1"/>
+          <p:nvPr/>
+        </p:nvSpPr>
+        <p:spPr>
+          <a:xfrm>
+            <a:off x="685800" y="6355080"/>
+            <a:ext cx="10817352" cy="274320"/>
+          </a:xfrm>
+          <a:prstGeom prst="rect">
+            <a:avLst/>
+          </a:prstGeom>
+          <a:noFill/>
+        </p:spPr>
+        <p:txBody>
+          <a:bodyPr wrap="none">
+            <a:spAutoFit/>
+          </a:bodyPr>
+          <a:lstStyle/>
+          <a:p>
+            <a:pPr algn="l"/>
+            <a:r>
+              <a:rPr sz="700">
+                <a:solidFill>
+                  <a:srgbClr val="8CA0C3"/>
+                </a:solidFill>
+                <a:latin typeface="Consolas"/>
+              </a:rPr>
+              <a:t>FKB Campus  ·  VA10</a:t>
+            </a:r>
+          </a:p>
+        </p:txBody>
+      </p:sp>
+    </p:spTree>
+  </p:cSld>
+  <p:clrMapOvr>
+    <a:masterClrMapping/>
+  </p:clrMapOvr>
+</p:sld>
+</file>
+
+<file path=ppt/slides/slide9.xml><?xml version="1.0" encoding="utf-8"?>
+<p:sld xmlns:a="http://schemas.openxmlformats.org/drawingml/2006/main" xmlns:p="http://schemas.openxmlformats.org/presentationml/2006/main" xmlns:r="http://schemas.openxmlformats.org/officeDocument/2006/relationships">
+  <p:cSld>
+    <p:spTree>
+      <p:nvGrpSpPr>
+        <p:cNvPr id="1" name=""/>
+        <p:cNvGrpSpPr/>
+        <p:nvPr/>
+      </p:nvGrpSpPr>
+      <p:grpSpPr/>
+      <p:sp>
+        <p:nvSpPr>
+          <p:cNvPr id="2" name="Rectangle 1"/>
+          <p:cNvSpPr/>
+          <p:nvPr/>
+        </p:nvSpPr>
+        <p:spPr>
+          <a:xfrm>
+            <a:off x="0" y="0"/>
+            <a:ext cx="12188952" cy="6858000"/>
+          </a:xfrm>
+          <a:prstGeom prst="rect">
+            <a:avLst/>
+          </a:prstGeom>
+          <a:solidFill>
             <a:srgbClr val="EDEDF3"/>
           </a:solidFill>
           <a:ln>
@@ -7557,7 +10418,7 @@
                 </a:solidFill>
                 <a:latin typeface="Arial"/>
               </a:rPr>
-              <a:t>Reflexionsfragen</a:t>
+              <a:t>Wer darf handeln? Vertretung nach Rechtsform</a:t>
             </a:r>
           </a:p>
         </p:txBody>
@@ -7583,6 +10444,25 @@
             <a:spAutoFit/>
           </a:bodyPr>
           <a:lstStyle/>
+          <a:p>
+            <a:pPr marL="177800" indent="-177800">
+              <a:spcBef>
+                <a:spcPts val="600"/>
+              </a:spcBef>
+              <a:spcAft>
+                <a:spcPts val="200"/>
+              </a:spcAft>
+            </a:pPr>
+            <a:r>
+              <a:rPr sz="1200" i="1">
+                <a:solidFill>
+                  <a:srgbClr val="3D5466"/>
+                </a:solidFill>
+                <a:latin typeface="Arial"/>
+              </a:rPr>
+              <a:t>→  Die Vertretungsregelung steht im Handelsregister – Einzel- oder Gesamtvertretung immer aus dem aktuellen HR-Auszug ablesen.</a:t>
+            </a:r>
+          </a:p>
           <a:p>
             <a:pPr marL="190500" indent="-190500">
               <a:spcBef>
@@ -7599,7 +10479,7 @@
                 </a:solidFill>
                 <a:latin typeface="Arial"/>
               </a:rPr>
-              <a:t>▸  Welche Rechtsform begegnet Ihnen in Ihrer täglichen Arbeit am häufigsten – und wie sicher fühlen Sie sich bislang bei der Prüfung der Vertretungsberechtigung?</a:t>
+              <a:t>▸  e.K.: Inhaber selbst, Prokura möglich. OHG: jeder Gesellschafter einzeln (Regelfall).</a:t>
             </a:r>
           </a:p>
           <a:p>
@@ -7618,7 +10498,7 @@
                 </a:solidFill>
                 <a:latin typeface="Arial"/>
               </a:rPr>
-              <a:t>▸  Stellen Sie sich vor, ein freundlicher Stammkunde möchte schnell ein neues Konto eröffnen und sagt: „Den Papierkram haben wir doch schon alles erledigt, einfach anlegen." Was antworten Sie – und wie begründen Sie das?</a:t>
+              <a:t>▸  GbR: alle Gesellschafter gemeinsam (§ 720 BGB n.F. seit MoPeG, 01.01.2024).</a:t>
             </a:r>
           </a:p>
           <a:p>
@@ -7637,7 +10517,7 @@
                 </a:solidFill>
                 <a:latin typeface="Arial"/>
               </a:rPr>
-              <a:t>▸  Woran erkennen Sie, dass ein Handelsregisterauszug für Ihre Zwecke nicht mehr aktuell genug ist?</a:t>
+              <a:t>▸  GmbH: Geschäftsführer laut HR. GmbH &amp; Co. KG: Komplementär-GmbH, vertreten durch deren Geschäftsführer – zwei Registerauszüge nötig.</a:t>
             </a:r>
           </a:p>
           <a:p>
@@ -7656,7 +10536,7 @@
                 </a:solidFill>
                 <a:latin typeface="Arial"/>
               </a:rPr>
-              <a:t>▸  Beschreiben Sie in zwei Sätzen, worin der Unterschied zwischen einer Prokura und einer BGB-Vollmacht liegt – und warum das für die Bankpraxis relevant ist.</a:t>
+              <a:t>▸  Prokura (ppa., §§ 48–53 HGB): häufiger Fehler ist der fehlende ppa.-Zusatz.</a:t>
             </a:r>
           </a:p>
         </p:txBody>

</xml_diff>